<commit_message>
Reframe row 3 as AX-PI handover to business unit (build is BU scope)
Co-Authored-By: Claude Opus 5.5 <noreply@anthropic.com>
Claude-Session: https://claude.ai/code/session_01WNEGybX95CXr34MGwdFDgp
</commit_message>
<xml_diff>
--- a/AX_Education_Task1.pptx
+++ b/AX_Education_Task1.pptx
@@ -107,7 +107,7 @@
   <p:extLst>
     <p:ext uri="{521415D9-36F7-43E2-AB2F-B90AF26B5E84}">
       <p14:sectionLst xmlns:p14="http://schemas.microsoft.com/office/powerpoint/2010/main">
-        <p14:section name="과제1 AX교육" id="{e631978b-d56c-1a7d-efab-a85de97a453b}">
+        <p14:section name="과제1 AX교육" id="{fab73d31-cf62-a215-5dd9-32c572f0d8b9}">
           <p14:sldIdLst>
             <p14:sldId id="256"/>
           </p14:sldIdLst>
@@ -516,7 +516,7 @@
           <a:p>
             <a:r>
               <a:rPr lang="en-US" dirty="0"/>
-              <a:t>왼쪽: 추진 프로세스 중 AX교육 단계의 배경·목적·범위. 오른쪽: 롯데백화점 이커머스 AX Inno-Camp('26.10.30)를 출발점으로 AX진단·Quick-Win 실증을 거쳐 '27 AI 기반 온/오프 통합 e커머스 서비스 구축 사업으로 이어지는 사업화 흐름. 행2·3 시기는 안(案)이며 실제 일정으로 수정 필요.</a:t>
+              <a:t>왼쪽: 추진 프로세스 중 AX교육 단계의 배경·목적·범위. 오른쪽: 롯데백화점 이커머스 AX Inno-Camp('26.10.30)를 출발점으로 AX진단·Quick-Win 실증을 거쳐 AX-PI로 To-Be·구축 요건을 정의해 사업부의 '27 AI 기반 온/오프 통합 e커머스 서비스 구축 사업으로 연계하는 사업화 흐름. 행2·3 시기는 안(案)이며 실제 일정으로 수정 필요.</a:t>
             </a:r>
             <a:endParaRPr lang="en-US" dirty="0"/>
           </a:p>
@@ -1407,6 +1407,20 @@
             </a:r>
             <a:endParaRPr lang="en-US" sz="1150" dirty="0"/>
           </a:p>
+          <a:p>
+            <a:pPr algn="ctr" indent="0" marL="0">
+              <a:buNone/>
+            </a:pPr>
+            <a:r>
+              <a:rPr lang="en-US" sz="1150" b="1" dirty="0">
+                <a:solidFill>
+                  <a:schemeClr val="accent5"/>
+                </a:solidFill>
+              </a:rPr>
+              <a:t>(사업부)</a:t>
+            </a:r>
+            <a:endParaRPr lang="en-US" sz="1150" dirty="0"/>
+          </a:p>
         </p:txBody>
       </p:sp>
       <p:sp>
@@ -1945,7 +1959,7 @@
                   <a:schemeClr val="accent3"/>
                 </a:solidFill>
               </a:rPr>
-              <a:t>▪ 현업 주도 과제 발굴 → 진단·실증 → 본사업 수주 연결 </a:t>
+              <a:t>▪ 현업 주도 과제 발굴 → 진단·실증 → 사업부 본사업 연계 </a:t>
             </a:r>
             <a:pPr indent="0" marL="0">
               <a:buNone/>
@@ -1956,7 +1970,7 @@
                   <a:schemeClr val="accent3"/>
                 </a:solidFill>
               </a:rPr>
-              <a:t>(교육 → 진단 → PI/Quick-Win → '27 구축)</a:t>
+              <a:t>(교육 → 진단 → PI/Quick-Win → 사업부 구축)</a:t>
             </a:r>
             <a:endParaRPr lang="en-US" sz="1250" dirty="0"/>
           </a:p>
@@ -3251,7 +3265,7 @@
                   <a:schemeClr val="tx1"/>
                 </a:solidFill>
               </a:rPr>
-              <a:t>본사업</a:t>
+              <a:t>AX-PI</a:t>
             </a:r>
             <a:endParaRPr lang="en-US" sz="1300" dirty="0"/>
           </a:p>
@@ -3265,7 +3279,7 @@
                   <a:schemeClr val="tx1"/>
                 </a:solidFill>
               </a:rPr>
-              <a:t>구축</a:t>
+              <a:t>사업 연계</a:t>
             </a:r>
             <a:endParaRPr lang="en-US" sz="1300" dirty="0"/>
           </a:p>
@@ -3326,7 +3340,7 @@
                   <a:schemeClr val="tx1"/>
                 </a:solidFill>
               </a:rPr>
-              <a:t>온/오프 고객 데이터·여정 단절 → </a:t>
+              <a:t>구축 범위·요건 불명확 → </a:t>
             </a:r>
             <a:pPr indent="0" marL="0">
               <a:buNone/>
@@ -3337,7 +3351,7 @@
                   <a:schemeClr val="accent3"/>
                 </a:solidFill>
               </a:rPr>
-              <a:t>AX-PI 기반 온/오프 통합 e커머스 구축</a:t>
+              <a:t>AX-PI로 To-Be·요건 정의, 사업부 본사업 연계</a:t>
             </a:r>
             <a:endParaRPr lang="en-US" sz="1250" dirty="0"/>
           </a:p>
@@ -3373,7 +3387,7 @@
                   <a:schemeClr val="accent5"/>
                 </a:solidFill>
               </a:rPr>
-              <a:t>e.g. '27 AI 기반 온/오프 통합 e커머스 서비스 구축 프로젝트</a:t>
+              <a:t>e.g. '27 AI 기반 온/오프 통합 e커머스 서비스 구축(사업부 수행) 범위 선점</a:t>
             </a:r>
             <a:endParaRPr lang="en-US" sz="1050" dirty="0"/>
           </a:p>
@@ -3490,7 +3504,7 @@
                   <a:schemeClr val="tx2"/>
                 </a:solidFill>
               </a:rPr>
-              <a:t>온/오프 통합 고객경험 필요</a:t>
+              <a:t>온/오프 고객 데이터·여정 단절</a:t>
             </a:r>
             <a:endParaRPr lang="en-US" sz="1200" dirty="0"/>
           </a:p>
@@ -3627,7 +3641,7 @@
                   <a:schemeClr val="bg1"/>
                 </a:solidFill>
               </a:rPr>
-              <a:t>AI 통합 e커머스 플랫폼</a:t>
+              <a:t>AX-PI (To-Be 설계)</a:t>
             </a:r>
             <a:endParaRPr lang="en-US" sz="1300" dirty="0"/>
           </a:p>
@@ -3764,7 +3778,7 @@
                   <a:schemeClr val="accent3"/>
                 </a:solidFill>
               </a:rPr>
-              <a:t>구축 사업 수주 / 매출 확대</a:t>
+              <a:t>사업부 구축 사업 수주 연계</a:t>
             </a:r>
             <a:endParaRPr lang="en-US" sz="1200" dirty="0"/>
           </a:p>
@@ -3800,7 +3814,7 @@
                   <a:schemeClr val="accent5"/>
                 </a:solidFill>
               </a:rPr>
-              <a:t>※ 통합 고객 데이터 /</a:t>
+              <a:t>※ 통합 고객여정 To-Be / 구축 요건·</a:t>
             </a:r>
             <a:endParaRPr lang="en-US" sz="850" dirty="0"/>
           </a:p>
@@ -3814,7 +3828,7 @@
                   <a:schemeClr val="accent5"/>
                 </a:solidFill>
               </a:rPr>
-              <a:t>개인화 추천·Agent 서비스</a:t>
+              <a:t>RFP 정의 → 사업부 이관</a:t>
             </a:r>
             <a:endParaRPr lang="en-US" sz="850" dirty="0"/>
           </a:p>

</xml_diff>

<commit_message>
Restructure right side into 추진 방안 / 기대 효과 / 세부운영 계획 rows
Co-Authored-By: Claude Opus 5.5 <noreply@anthropic.com>
Claude-Session: https://claude.ai/code/session_01WNEGybX95CXr34MGwdFDgp
</commit_message>
<xml_diff>
--- a/AX_Education_Task1.pptx
+++ b/AX_Education_Task1.pptx
@@ -107,7 +107,7 @@
   <p:extLst>
     <p:ext uri="{521415D9-36F7-43E2-AB2F-B90AF26B5E84}">
       <p14:sectionLst xmlns:p14="http://schemas.microsoft.com/office/powerpoint/2010/main">
-        <p14:section name="과제1 AX교육" id="{fab73d31-cf62-a215-5dd9-32c572f0d8b9}">
+        <p14:section name="과제1 AX교육" id="{1620c140-9431-36f3-bdad-fff7d9b6db3b}">
           <p14:sldIdLst>
             <p14:sldId id="256"/>
           </p14:sldIdLst>
@@ -516,7 +516,7 @@
           <a:p>
             <a:r>
               <a:rPr lang="en-US" dirty="0"/>
-              <a:t>왼쪽: 추진 프로세스 중 AX교육 단계의 배경·목적·범위. 오른쪽: 롯데백화점 이커머스 AX Inno-Camp('26.10.30)를 출발점으로 AX진단·Quick-Win 실증을 거쳐 AX-PI로 To-Be·구축 요건을 정의해 사업부의 '27 AI 기반 온/오프 통합 e커머스 서비스 구축 사업으로 연계하는 사업화 흐름. 행2·3 시기는 안(案)이며 실제 일정으로 수정 필요.</a:t>
+              <a:t>왼쪽: 추진 프로세스 중 AX교육 단계의 배경·목적·범위. 오른쪽: AX Inno-Camp의 추진 방안(데이터 기반 인사이트 → Agent 과제 설계 → 직접 구현), 기대 효과(현업·과제·사업 측면), 롯데백화점 이커머스 세부운영 계획('26.10.30 Camp → 진단·PI → 사업부 '27 온/오프 통합 e커머스 구축 연계). 투입 인원 N과 '26.10/'26.11 일정은 안(案)이며 실제 값으로 수정 필요.</a:t>
             </a:r>
             <a:endParaRPr lang="en-US" dirty="0"/>
           </a:p>
@@ -1923,7 +1923,7 @@
                   <a:schemeClr val="accent1"/>
                 </a:solidFill>
               </a:rPr>
-              <a:t>AX교육 기반 사업화 Approach (e.g. 롯데백화점)</a:t>
+              <a:t>AX교육 Approach (AX Inno-Camp)</a:t>
             </a:r>
             <a:endParaRPr lang="en-US" sz="1500" dirty="0"/>
           </a:p>
@@ -1959,18 +1959,18 @@
                   <a:schemeClr val="accent3"/>
                 </a:solidFill>
               </a:rPr>
-              <a:t>▪ 현업 주도 과제 발굴 → 진단·실증 → 사업부 본사업 연계 </a:t>
+              <a:t>▪ 현업 업무·데이터에서 출발하는 실습형 교육 </a:t>
             </a:r>
             <a:pPr indent="0" marL="0">
               <a:buNone/>
             </a:pPr>
             <a:r>
-              <a:rPr lang="en-US" sz="1000" dirty="0">
+              <a:rPr lang="en-US" sz="1250" b="1" dirty="0">
                 <a:solidFill>
                   <a:schemeClr val="accent3"/>
                 </a:solidFill>
               </a:rPr>
-              <a:t>(교육 → 진단 → PI/Quick-Win → 사업부 구축)</a:t>
+              <a:t>→ AX 과제 발굴 → 진단 → 사업부 본사업 연계</a:t>
             </a:r>
             <a:endParaRPr lang="en-US" sz="1250" dirty="0"/>
           </a:p>
@@ -1991,7 +1991,7 @@
             <a:avLst/>
           </a:prstGeom>
           <a:solidFill>
-            <a:schemeClr val="bg1"/>
+            <a:schemeClr val="bg2"/>
           </a:solidFill>
           <a:ln w="9525">
             <a:solidFill>
@@ -2031,129 +2031,101 @@
                   <a:schemeClr val="tx1"/>
                 </a:solidFill>
               </a:rPr>
-              <a:t>교육</a:t>
+              <a:t>추진 방안</a:t>
             </a:r>
             <a:endParaRPr lang="en-US" sz="1300" dirty="0"/>
           </a:p>
-          <a:p>
-            <a:pPr algn="ctr" indent="0" marL="0">
-              <a:buNone/>
-            </a:pPr>
-            <a:r>
-              <a:rPr lang="en-US" sz="1300" b="1" dirty="0">
+        </p:txBody>
+      </p:sp>
+      <p:sp>
+        <p:nvSpPr>
+          <p:cNvPr id="32" name="Text 30"/>
+          <p:cNvSpPr txBox="1"/>
+          <p:nvPr/>
+        </p:nvSpPr>
+        <p:spPr>
+          <a:xfrm>
+            <a:off x="5559552" y="1911096"/>
+            <a:ext cx="6035040" cy="274320"/>
+          </a:xfrm>
+          <a:prstGeom prst="rect">
+            <a:avLst/>
+          </a:prstGeom>
+          <a:noFill/>
+          <a:ln/>
+        </p:spPr>
+        <p:txBody>
+          <a:bodyPr wrap="square" lIns="0" tIns="0" rIns="0" bIns="0" rtlCol="0" anchor="ctr"/>
+          <a:lstStyle/>
+          <a:p>
+            <a:pPr indent="0" marL="0">
+              <a:buNone/>
+            </a:pPr>
+            <a:r>
+              <a:rPr lang="en-US" sz="1250" dirty="0">
+                <a:solidFill>
+                  <a:schemeClr val="accent5"/>
+                </a:solidFill>
+              </a:rPr>
+              <a:t>• </a:t>
+            </a:r>
+            <a:pPr indent="0" marL="0">
+              <a:buNone/>
+            </a:pPr>
+            <a:r>
+              <a:rPr lang="en-US" sz="1250" b="1" dirty="0">
                 <a:solidFill>
                   <a:schemeClr val="tx1"/>
                 </a:solidFill>
               </a:rPr>
-              <a:t>Open Door</a:t>
-            </a:r>
-            <a:endParaRPr lang="en-US" sz="1300" dirty="0"/>
-          </a:p>
-          <a:p>
-            <a:pPr algn="ctr" indent="0" marL="0">
-              <a:buNone/>
-            </a:pPr>
-            <a:r>
-              <a:rPr lang="en-US" sz="950" dirty="0">
+              <a:t>업무 경험·데이터에서 출발 → </a:t>
+            </a:r>
+            <a:pPr indent="0" marL="0">
+              <a:buNone/>
+            </a:pPr>
+            <a:r>
+              <a:rPr lang="en-US" sz="1250" b="1" dirty="0">
+                <a:solidFill>
+                  <a:schemeClr val="accent3"/>
+                </a:solidFill>
+              </a:rPr>
+              <a:t>현업이 AI Agent 과제를 발굴·설계·구현</a:t>
+            </a:r>
+            <a:endParaRPr lang="en-US" sz="1250" dirty="0"/>
+          </a:p>
+        </p:txBody>
+      </p:sp>
+      <p:sp>
+        <p:nvSpPr>
+          <p:cNvPr id="33" name="Text 31"/>
+          <p:cNvSpPr txBox="1"/>
+          <p:nvPr/>
+        </p:nvSpPr>
+        <p:spPr>
+          <a:xfrm>
+            <a:off x="5715000" y="2176272"/>
+            <a:ext cx="5897880" cy="237744"/>
+          </a:xfrm>
+          <a:prstGeom prst="rect">
+            <a:avLst/>
+          </a:prstGeom>
+          <a:noFill/>
+          <a:ln/>
+        </p:spPr>
+        <p:txBody>
+          <a:bodyPr wrap="square" lIns="0" tIns="0" rIns="0" bIns="0" rtlCol="0" anchor="ctr"/>
+          <a:lstStyle/>
+          <a:p>
+            <a:pPr indent="0" marL="0">
+              <a:buNone/>
+            </a:pPr>
+            <a:r>
+              <a:rPr lang="en-US" sz="1050" dirty="0">
                 <a:solidFill>
                   <a:schemeClr val="accent5"/>
                 </a:solidFill>
               </a:rPr>
-              <a:t>'26.10</a:t>
-            </a:r>
-            <a:endParaRPr lang="en-US" sz="1300" dirty="0"/>
-          </a:p>
-        </p:txBody>
-      </p:sp>
-      <p:sp>
-        <p:nvSpPr>
-          <p:cNvPr id="32" name="Text 30"/>
-          <p:cNvSpPr txBox="1"/>
-          <p:nvPr/>
-        </p:nvSpPr>
-        <p:spPr>
-          <a:xfrm>
-            <a:off x="5559552" y="1911096"/>
-            <a:ext cx="5989320" cy="274320"/>
-          </a:xfrm>
-          <a:prstGeom prst="rect">
-            <a:avLst/>
-          </a:prstGeom>
-          <a:noFill/>
-          <a:ln/>
-        </p:spPr>
-        <p:txBody>
-          <a:bodyPr wrap="square" lIns="0" tIns="0" rIns="0" bIns="0" rtlCol="0" anchor="ctr"/>
-          <a:lstStyle/>
-          <a:p>
-            <a:pPr indent="0" marL="0">
-              <a:buNone/>
-            </a:pPr>
-            <a:r>
-              <a:rPr lang="en-US" sz="1250" dirty="0">
-                <a:solidFill>
-                  <a:schemeClr val="accent5"/>
-                </a:solidFill>
-              </a:rPr>
-              <a:t>• </a:t>
-            </a:r>
-            <a:pPr indent="0" marL="0">
-              <a:buNone/>
-            </a:pPr>
-            <a:r>
-              <a:rPr lang="en-US" sz="1250" b="1" dirty="0">
-                <a:solidFill>
-                  <a:schemeClr val="tx1"/>
-                </a:solidFill>
-              </a:rPr>
-              <a:t>현업 AI 활용 경험 부족 → </a:t>
-            </a:r>
-            <a:pPr indent="0" marL="0">
-              <a:buNone/>
-            </a:pPr>
-            <a:r>
-              <a:rPr lang="en-US" sz="1250" b="1" dirty="0">
-                <a:solidFill>
-                  <a:schemeClr val="accent3"/>
-                </a:solidFill>
-              </a:rPr>
-              <a:t>실습형 AX Inno-Camp로 현업 주도 과제 발굴</a:t>
-            </a:r>
-            <a:endParaRPr lang="en-US" sz="1250" dirty="0"/>
-          </a:p>
-        </p:txBody>
-      </p:sp>
-      <p:sp>
-        <p:nvSpPr>
-          <p:cNvPr id="33" name="Text 31"/>
-          <p:cNvSpPr txBox="1"/>
-          <p:nvPr/>
-        </p:nvSpPr>
-        <p:spPr>
-          <a:xfrm>
-            <a:off x="5715000" y="2185416"/>
-            <a:ext cx="5852160" cy="237744"/>
-          </a:xfrm>
-          <a:prstGeom prst="rect">
-            <a:avLst/>
-          </a:prstGeom>
-          <a:noFill/>
-          <a:ln/>
-        </p:spPr>
-        <p:txBody>
-          <a:bodyPr wrap="square" lIns="0" tIns="0" rIns="0" bIns="0" rtlCol="0" anchor="ctr"/>
-          <a:lstStyle/>
-          <a:p>
-            <a:pPr indent="0" marL="0">
-              <a:buNone/>
-            </a:pPr>
-            <a:r>
-              <a:rPr lang="en-US" sz="1050" dirty="0">
-                <a:solidFill>
-                  <a:schemeClr val="accent5"/>
-                </a:solidFill>
-              </a:rPr>
-              <a:t>e.g. [롯데백화점 이커머스] 가상 데이터 6종 기반 고객 인사이트 도출 → Agent 기획·구현</a:t>
+              <a:t>e.g. [롯데백화점 이커머스] 가상 데이터 6종으로 고객 분석 → Agent 기획 → 구현</a:t>
             </a:r>
             <a:endParaRPr lang="en-US" sz="1050" dirty="0"/>
           </a:p>
@@ -2167,8 +2139,8 @@
         </p:nvSpPr>
         <p:spPr>
           <a:xfrm>
-            <a:off x="5577840" y="2478024"/>
-            <a:ext cx="1783080" cy="603504"/>
+            <a:off x="5577840" y="2459736"/>
+            <a:ext cx="1810512" cy="676656"/>
           </a:xfrm>
           <a:prstGeom prst="rect">
             <a:avLst/>
@@ -2192,8 +2164,8 @@
         </p:nvSpPr>
         <p:spPr>
           <a:xfrm>
-            <a:off x="5577840" y="2478024"/>
-            <a:ext cx="685800" cy="182880"/>
+            <a:off x="5577840" y="2459736"/>
+            <a:ext cx="566928" cy="182880"/>
           </a:xfrm>
           <a:prstGeom prst="rect">
             <a:avLst/>
@@ -2212,8 +2184,8 @@
         </p:nvSpPr>
         <p:spPr>
           <a:xfrm>
-            <a:off x="5577840" y="2478024"/>
-            <a:ext cx="685800" cy="182880"/>
+            <a:off x="5577840" y="2459736"/>
+            <a:ext cx="566928" cy="182880"/>
           </a:xfrm>
           <a:prstGeom prst="rect">
             <a:avLst/>
@@ -2234,7 +2206,7 @@
                   <a:schemeClr val="bg1"/>
                 </a:solidFill>
               </a:rPr>
-              <a:t>이슈</a:t>
+              <a:t>01</a:t>
             </a:r>
             <a:endParaRPr lang="en-US" sz="900" dirty="0"/>
           </a:p>
@@ -2248,8 +2220,8 @@
         </p:nvSpPr>
         <p:spPr>
           <a:xfrm>
-            <a:off x="5650992" y="2660904"/>
-            <a:ext cx="1636776" cy="420624"/>
+            <a:off x="5632704" y="2642616"/>
+            <a:ext cx="1700784" cy="493776"/>
           </a:xfrm>
           <a:prstGeom prst="rect">
             <a:avLst/>
@@ -2267,10 +2239,24 @@
             <a:r>
               <a:rPr lang="en-US" sz="1200" b="1" dirty="0">
                 <a:solidFill>
+                  <a:schemeClr val="tx1"/>
+                </a:solidFill>
+              </a:rPr>
+              <a:t>데이터 기반 인사이트</a:t>
+            </a:r>
+            <a:endParaRPr lang="en-US" sz="1200" dirty="0"/>
+          </a:p>
+          <a:p>
+            <a:pPr algn="ctr" indent="0" marL="0">
+              <a:buNone/>
+            </a:pPr>
+            <a:r>
+              <a:rPr lang="en-US" sz="900" dirty="0">
+                <a:solidFill>
                   <a:schemeClr val="tx2"/>
                 </a:solidFill>
               </a:rPr>
-              <a:t>현업 AX 공감대·과제 부재</a:t>
+              <a:t>고객군·여정·Pain Point 도출</a:t>
             </a:r>
             <a:endParaRPr lang="en-US" sz="1200" dirty="0"/>
           </a:p>
@@ -2284,7 +2270,7 @@
         </p:nvSpPr>
         <p:spPr>
           <a:xfrm rot="5400000">
-            <a:off x="7351776" y="2642616"/>
+            <a:off x="7370064" y="2715768"/>
             <a:ext cx="274320" cy="164592"/>
           </a:xfrm>
           <a:prstGeom prst="triangle">
@@ -2304,8 +2290,8 @@
         </p:nvSpPr>
         <p:spPr>
           <a:xfrm>
-            <a:off x="7653528" y="2478024"/>
-            <a:ext cx="1874520" cy="603504"/>
+            <a:off x="7662672" y="2459736"/>
+            <a:ext cx="1847088" cy="676656"/>
           </a:xfrm>
           <a:prstGeom prst="rect">
             <a:avLst/>
@@ -2329,8 +2315,8 @@
         </p:nvSpPr>
         <p:spPr>
           <a:xfrm>
-            <a:off x="7653528" y="2478024"/>
-            <a:ext cx="685800" cy="182880"/>
+            <a:off x="7662672" y="2459736"/>
+            <a:ext cx="566928" cy="182880"/>
           </a:xfrm>
           <a:prstGeom prst="rect">
             <a:avLst/>
@@ -2349,8 +2335,8 @@
         </p:nvSpPr>
         <p:spPr>
           <a:xfrm>
-            <a:off x="7653528" y="2478024"/>
-            <a:ext cx="685800" cy="182880"/>
+            <a:off x="7662672" y="2459736"/>
+            <a:ext cx="566928" cy="182880"/>
           </a:xfrm>
           <a:prstGeom prst="rect">
             <a:avLst/>
@@ -2371,7 +2357,7 @@
                   <a:schemeClr val="bg1"/>
                 </a:solidFill>
               </a:rPr>
-              <a:t>AX 활동</a:t>
+              <a:t>02</a:t>
             </a:r>
             <a:endParaRPr lang="en-US" sz="900" dirty="0"/>
           </a:p>
@@ -2385,8 +2371,8 @@
         </p:nvSpPr>
         <p:spPr>
           <a:xfrm>
-            <a:off x="7726680" y="2660904"/>
-            <a:ext cx="1728216" cy="420624"/>
+            <a:off x="7717536" y="2642616"/>
+            <a:ext cx="1737360" cy="493776"/>
           </a:xfrm>
           <a:prstGeom prst="rect">
             <a:avLst/>
@@ -2402,14 +2388,28 @@
               <a:buNone/>
             </a:pPr>
             <a:r>
-              <a:rPr lang="en-US" sz="1300" b="1" dirty="0">
+              <a:rPr lang="en-US" sz="1200" b="1" dirty="0">
                 <a:solidFill>
                   <a:schemeClr val="bg1"/>
                 </a:solidFill>
               </a:rPr>
-              <a:t>AX Inno-Camp</a:t>
-            </a:r>
-            <a:endParaRPr lang="en-US" sz="1300" dirty="0"/>
+              <a:t>AI Agent 과제 설계</a:t>
+            </a:r>
+            <a:endParaRPr lang="en-US" sz="1200" dirty="0"/>
+          </a:p>
+          <a:p>
+            <a:pPr algn="ctr" indent="0" marL="0">
+              <a:buNone/>
+            </a:pPr>
+            <a:r>
+              <a:rPr lang="en-US" sz="900" dirty="0">
+                <a:solidFill>
+                  <a:schemeClr val="bg1"/>
+                </a:solidFill>
+              </a:rPr>
+              <a:t>AI 활용 기회 발굴, Agent 기획서</a:t>
+            </a:r>
+            <a:endParaRPr lang="en-US" sz="1200" dirty="0"/>
           </a:p>
         </p:txBody>
       </p:sp>
@@ -2421,7 +2421,7 @@
         </p:nvSpPr>
         <p:spPr>
           <a:xfrm rot="5400000">
-            <a:off x="9518904" y="2642616"/>
+            <a:off x="9491472" y="2715768"/>
             <a:ext cx="274320" cy="164592"/>
           </a:xfrm>
           <a:prstGeom prst="triangle">
@@ -2441,8 +2441,8 @@
         </p:nvSpPr>
         <p:spPr>
           <a:xfrm>
-            <a:off x="9820656" y="2478024"/>
-            <a:ext cx="1737360" cy="603504"/>
+            <a:off x="9784080" y="2459736"/>
+            <a:ext cx="1810512" cy="676656"/>
           </a:xfrm>
           <a:prstGeom prst="rect">
             <a:avLst/>
@@ -2466,8 +2466,8 @@
         </p:nvSpPr>
         <p:spPr>
           <a:xfrm>
-            <a:off x="9820656" y="2478024"/>
-            <a:ext cx="685800" cy="182880"/>
+            <a:off x="9784080" y="2459736"/>
+            <a:ext cx="566928" cy="182880"/>
           </a:xfrm>
           <a:prstGeom prst="rect">
             <a:avLst/>
@@ -2486,8 +2486,8 @@
         </p:nvSpPr>
         <p:spPr>
           <a:xfrm>
-            <a:off x="9820656" y="2478024"/>
-            <a:ext cx="685800" cy="182880"/>
+            <a:off x="9784080" y="2459736"/>
+            <a:ext cx="566928" cy="182880"/>
           </a:xfrm>
           <a:prstGeom prst="rect">
             <a:avLst/>
@@ -2508,7 +2508,7 @@
                   <a:schemeClr val="bg1"/>
                 </a:solidFill>
               </a:rPr>
-              <a:t>기대효과</a:t>
+              <a:t>03</a:t>
             </a:r>
             <a:endParaRPr lang="en-US" sz="900" dirty="0"/>
           </a:p>
@@ -2522,8 +2522,8 @@
         </p:nvSpPr>
         <p:spPr>
           <a:xfrm>
-            <a:off x="9893808" y="2660904"/>
-            <a:ext cx="1591056" cy="420624"/>
+            <a:off x="9838944" y="2642616"/>
+            <a:ext cx="1700784" cy="493776"/>
           </a:xfrm>
           <a:prstGeom prst="rect">
             <a:avLst/>
@@ -2541,13 +2541,27 @@
             <a:r>
               <a:rPr lang="en-US" sz="1200" b="1" dirty="0">
                 <a:solidFill>
-                  <a:schemeClr val="accent3"/>
-                </a:solidFill>
-              </a:rPr>
-              <a:t>현업 주도 AX 과제 Pool 확보</a:t>
+                  <a:schemeClr val="tx1"/>
+                </a:solidFill>
+              </a:rPr>
+              <a:t>직접 구현·검증</a:t>
             </a:r>
             <a:endParaRPr lang="en-US" sz="1200" dirty="0"/>
           </a:p>
+          <a:p>
+            <a:pPr algn="ctr" indent="0" marL="0">
+              <a:buNone/>
+            </a:pPr>
+            <a:r>
+              <a:rPr lang="en-US" sz="900" dirty="0">
+                <a:solidFill>
+                  <a:schemeClr val="tx2"/>
+                </a:solidFill>
+              </a:rPr>
+              <a:t>CodeAgent/Onflow 구현</a:t>
+            </a:r>
+            <a:endParaRPr lang="en-US" sz="1200" dirty="0"/>
+          </a:p>
         </p:txBody>
       </p:sp>
       <p:sp>
@@ -2558,8 +2572,8 @@
         </p:nvSpPr>
         <p:spPr>
           <a:xfrm>
-            <a:off x="7498080" y="3090672"/>
-            <a:ext cx="2194560" cy="274320"/>
+            <a:off x="5577840" y="3172968"/>
+            <a:ext cx="6016752" cy="201168"/>
           </a:xfrm>
           <a:prstGeom prst="rect">
             <a:avLst/>
@@ -2575,28 +2589,14 @@
               <a:buNone/>
             </a:pPr>
             <a:r>
-              <a:rPr lang="en-US" sz="850" dirty="0">
+              <a:rPr lang="en-US" sz="900" dirty="0">
                 <a:solidFill>
                   <a:schemeClr val="accent5"/>
                 </a:solidFill>
               </a:rPr>
-              <a:t>※ 고객 데이터 분석 / Agent 기획서 /</a:t>
-            </a:r>
-            <a:endParaRPr lang="en-US" sz="850" dirty="0"/>
-          </a:p>
-          <a:p>
-            <a:pPr algn="ctr" indent="0" marL="0">
-              <a:buNone/>
-            </a:pPr>
-            <a:r>
-              <a:rPr lang="en-US" sz="850" dirty="0">
-                <a:solidFill>
-                  <a:schemeClr val="accent5"/>
-                </a:solidFill>
-              </a:rPr>
-              <a:t>프로토타입 3종</a:t>
-            </a:r>
-            <a:endParaRPr lang="en-US" sz="850" dirty="0"/>
+              <a:t>※ Co-Creation: 현업(참가자) + AX 컨설팅팀(퍼실리테이터) + AI 혁신센터·D&amp;AX(AI 전문가)</a:t>
+            </a:r>
+            <a:endParaRPr lang="en-US" sz="900" dirty="0"/>
           </a:p>
         </p:txBody>
       </p:sp>
@@ -2615,7 +2615,7 @@
             <a:avLst/>
           </a:prstGeom>
           <a:solidFill>
-            <a:schemeClr val="bg1"/>
+            <a:schemeClr val="bg2"/>
           </a:solidFill>
           <a:ln w="9525">
             <a:solidFill>
@@ -2655,36 +2655,80 @@
                   <a:schemeClr val="tx1"/>
                 </a:solidFill>
               </a:rPr>
-              <a:t>진단·실증</a:t>
+              <a:t>기대 효과</a:t>
             </a:r>
             <a:endParaRPr lang="en-US" sz="1300" dirty="0"/>
           </a:p>
-          <a:p>
-            <a:pPr algn="ctr" indent="0" marL="0">
-              <a:buNone/>
-            </a:pPr>
-            <a:r>
-              <a:rPr lang="en-US" sz="950" dirty="0">
+        </p:txBody>
+      </p:sp>
+      <p:sp>
+        <p:nvSpPr>
+          <p:cNvPr id="51" name="Text 49"/>
+          <p:cNvSpPr txBox="1"/>
+          <p:nvPr/>
+        </p:nvSpPr>
+        <p:spPr>
+          <a:xfrm>
+            <a:off x="5559552" y="3493008"/>
+            <a:ext cx="6035040" cy="274320"/>
+          </a:xfrm>
+          <a:prstGeom prst="rect">
+            <a:avLst/>
+          </a:prstGeom>
+          <a:noFill/>
+          <a:ln/>
+        </p:spPr>
+        <p:txBody>
+          <a:bodyPr wrap="square" lIns="0" tIns="0" rIns="0" bIns="0" rtlCol="0" anchor="ctr"/>
+          <a:lstStyle/>
+          <a:p>
+            <a:pPr indent="0" marL="0">
+              <a:buNone/>
+            </a:pPr>
+            <a:r>
+              <a:rPr lang="en-US" sz="1250" dirty="0">
                 <a:solidFill>
                   <a:schemeClr val="accent5"/>
                 </a:solidFill>
               </a:rPr>
-              <a:t>'26.4Q~'27.1H</a:t>
-            </a:r>
-            <a:endParaRPr lang="en-US" sz="1300" dirty="0"/>
-          </a:p>
-        </p:txBody>
-      </p:sp>
-      <p:sp>
-        <p:nvSpPr>
-          <p:cNvPr id="51" name="Text 49"/>
-          <p:cNvSpPr txBox="1"/>
-          <p:nvPr/>
-        </p:nvSpPr>
-        <p:spPr>
-          <a:xfrm>
-            <a:off x="5559552" y="3493008"/>
-            <a:ext cx="5989320" cy="274320"/>
+              <a:t>• </a:t>
+            </a:r>
+            <a:pPr indent="0" marL="0">
+              <a:buNone/>
+            </a:pPr>
+            <a:r>
+              <a:rPr lang="en-US" sz="1250" b="1" dirty="0">
+                <a:solidFill>
+                  <a:schemeClr val="tx1"/>
+                </a:solidFill>
+              </a:rPr>
+              <a:t>교육 산출물 = AX진단 입력물 → </a:t>
+            </a:r>
+            <a:pPr indent="0" marL="0">
+              <a:buNone/>
+            </a:pPr>
+            <a:r>
+              <a:rPr lang="en-US" sz="1250" b="1" dirty="0">
+                <a:solidFill>
+                  <a:schemeClr val="accent3"/>
+                </a:solidFill>
+              </a:rPr>
+              <a:t>일회성 교육이 아닌 사업 파이프라인</a:t>
+            </a:r>
+            <a:endParaRPr lang="en-US" sz="1250" dirty="0"/>
+          </a:p>
+        </p:txBody>
+      </p:sp>
+      <p:sp>
+        <p:nvSpPr>
+          <p:cNvPr id="52" name="Text 50"/>
+          <p:cNvSpPr txBox="1"/>
+          <p:nvPr/>
+        </p:nvSpPr>
+        <p:spPr>
+          <a:xfrm>
+            <a:off x="5715000" y="3758184"/>
+            <a:ext cx="5897880" cy="237744"/>
           </a:xfrm>
           <a:prstGeom prst="rect">
             <a:avLst/>
@@ -2700,70 +2744,12 @@
               <a:buNone/>
             </a:pPr>
             <a:r>
-              <a:rPr lang="en-US" sz="1250" dirty="0">
+              <a:rPr lang="en-US" sz="1050" dirty="0">
                 <a:solidFill>
                   <a:schemeClr val="accent5"/>
                 </a:solidFill>
               </a:rPr>
-              <a:t>• </a:t>
-            </a:r>
-            <a:pPr indent="0" marL="0">
-              <a:buNone/>
-            </a:pPr>
-            <a:r>
-              <a:rPr lang="en-US" sz="1250" b="1" dirty="0">
-                <a:solidFill>
-                  <a:schemeClr val="tx1"/>
-                </a:solidFill>
-              </a:rPr>
-              <a:t>교육 과제 실현성 검증 필요 → </a:t>
-            </a:r>
-            <a:pPr indent="0" marL="0">
-              <a:buNone/>
-            </a:pPr>
-            <a:r>
-              <a:rPr lang="en-US" sz="1250" b="1" dirty="0">
-                <a:solidFill>
-                  <a:schemeClr val="accent3"/>
-                </a:solidFill>
-              </a:rPr>
-              <a:t>AX진단으로 과제 구조화, Quick-Win으로 실증</a:t>
-            </a:r>
-            <a:endParaRPr lang="en-US" sz="1250" dirty="0"/>
-          </a:p>
-        </p:txBody>
-      </p:sp>
-      <p:sp>
-        <p:nvSpPr>
-          <p:cNvPr id="52" name="Text 50"/>
-          <p:cNvSpPr txBox="1"/>
-          <p:nvPr/>
-        </p:nvSpPr>
-        <p:spPr>
-          <a:xfrm>
-            <a:off x="5715000" y="3767328"/>
-            <a:ext cx="5852160" cy="237744"/>
-          </a:xfrm>
-          <a:prstGeom prst="rect">
-            <a:avLst/>
-          </a:prstGeom>
-          <a:noFill/>
-          <a:ln/>
-        </p:spPr>
-        <p:txBody>
-          <a:bodyPr wrap="square" lIns="0" tIns="0" rIns="0" bIns="0" rtlCol="0" anchor="ctr"/>
-          <a:lstStyle/>
-          <a:p>
-            <a:pPr indent="0" marL="0">
-              <a:buNone/>
-            </a:pPr>
-            <a:r>
-              <a:rPr lang="en-US" sz="1050" dirty="0">
-                <a:solidFill>
-                  <a:schemeClr val="accent5"/>
-                </a:solidFill>
-              </a:rPr>
-              <a:t>e.g. 교육 도출 CRM·고객여정 과제 고도화 → AX-PI / Quick-Win 유형 분류</a:t>
+              <a:t>e.g. 타사 Innovation Camp는 아이디어·설계에서 종료 ↔ 당사는 구현 실습 + 진단·PI 연계</a:t>
             </a:r>
             <a:endParaRPr lang="en-US" sz="1050" dirty="0"/>
           </a:p>
@@ -2777,8 +2763,8 @@
         </p:nvSpPr>
         <p:spPr>
           <a:xfrm>
-            <a:off x="5577840" y="4059936"/>
-            <a:ext cx="1783080" cy="603504"/>
+            <a:off x="5577840" y="4041648"/>
+            <a:ext cx="1810512" cy="676656"/>
           </a:xfrm>
           <a:prstGeom prst="rect">
             <a:avLst/>
@@ -2802,8 +2788,8 @@
         </p:nvSpPr>
         <p:spPr>
           <a:xfrm>
-            <a:off x="5577840" y="4059936"/>
-            <a:ext cx="685800" cy="182880"/>
+            <a:off x="5577840" y="4041648"/>
+            <a:ext cx="566928" cy="182880"/>
           </a:xfrm>
           <a:prstGeom prst="rect">
             <a:avLst/>
@@ -2822,8 +2808,8 @@
         </p:nvSpPr>
         <p:spPr>
           <a:xfrm>
-            <a:off x="5577840" y="4059936"/>
-            <a:ext cx="685800" cy="182880"/>
+            <a:off x="5577840" y="4041648"/>
+            <a:ext cx="566928" cy="182880"/>
           </a:xfrm>
           <a:prstGeom prst="rect">
             <a:avLst/>
@@ -2844,7 +2830,7 @@
                   <a:schemeClr val="bg1"/>
                 </a:solidFill>
               </a:rPr>
-              <a:t>이슈</a:t>
+              <a:t>현업</a:t>
             </a:r>
             <a:endParaRPr lang="en-US" sz="900" dirty="0"/>
           </a:p>
@@ -2858,8 +2844,8 @@
         </p:nvSpPr>
         <p:spPr>
           <a:xfrm>
-            <a:off x="5650992" y="4242816"/>
-            <a:ext cx="1636776" cy="420624"/>
+            <a:off x="5632704" y="4224528"/>
+            <a:ext cx="1700784" cy="493776"/>
           </a:xfrm>
           <a:prstGeom prst="rect">
             <a:avLst/>
@@ -2877,10 +2863,24 @@
             <a:r>
               <a:rPr lang="en-US" sz="1200" b="1" dirty="0">
                 <a:solidFill>
+                  <a:schemeClr val="tx1"/>
+                </a:solidFill>
+              </a:rPr>
+              <a:t>현업 주도 변화관리</a:t>
+            </a:r>
+            <a:endParaRPr lang="en-US" sz="1200" dirty="0"/>
+          </a:p>
+          <a:p>
+            <a:pPr algn="ctr" indent="0" marL="0">
+              <a:buNone/>
+            </a:pPr>
+            <a:r>
+              <a:rPr lang="en-US" sz="900" dirty="0">
+                <a:solidFill>
                   <a:schemeClr val="tx2"/>
                 </a:solidFill>
               </a:rPr>
-              <a:t>과제 실현성·효과 불확실</a:t>
+              <a:t>AX 역량·공감대 확보</a:t>
             </a:r>
             <a:endParaRPr lang="en-US" sz="1200" dirty="0"/>
           </a:p>
@@ -2894,7 +2894,7 @@
         </p:nvSpPr>
         <p:spPr>
           <a:xfrm rot="5400000">
-            <a:off x="7351776" y="4224528"/>
+            <a:off x="7370064" y="4297680"/>
             <a:ext cx="274320" cy="164592"/>
           </a:xfrm>
           <a:prstGeom prst="triangle">
@@ -2914,8 +2914,8 @@
         </p:nvSpPr>
         <p:spPr>
           <a:xfrm>
-            <a:off x="7653528" y="4059936"/>
-            <a:ext cx="1874520" cy="603504"/>
+            <a:off x="7662672" y="4041648"/>
+            <a:ext cx="1847088" cy="676656"/>
           </a:xfrm>
           <a:prstGeom prst="rect">
             <a:avLst/>
@@ -2939,8 +2939,8 @@
         </p:nvSpPr>
         <p:spPr>
           <a:xfrm>
-            <a:off x="7653528" y="4059936"/>
-            <a:ext cx="685800" cy="182880"/>
+            <a:off x="7662672" y="4041648"/>
+            <a:ext cx="566928" cy="182880"/>
           </a:xfrm>
           <a:prstGeom prst="rect">
             <a:avLst/>
@@ -2959,8 +2959,8 @@
         </p:nvSpPr>
         <p:spPr>
           <a:xfrm>
-            <a:off x="7653528" y="4059936"/>
-            <a:ext cx="685800" cy="182880"/>
+            <a:off x="7662672" y="4041648"/>
+            <a:ext cx="566928" cy="182880"/>
           </a:xfrm>
           <a:prstGeom prst="rect">
             <a:avLst/>
@@ -2981,7 +2981,7 @@
                   <a:schemeClr val="bg1"/>
                 </a:solidFill>
               </a:rPr>
-              <a:t>AX 활동</a:t>
+              <a:t>과제</a:t>
             </a:r>
             <a:endParaRPr lang="en-US" sz="900" dirty="0"/>
           </a:p>
@@ -2995,8 +2995,8 @@
         </p:nvSpPr>
         <p:spPr>
           <a:xfrm>
-            <a:off x="7726680" y="4242816"/>
-            <a:ext cx="1728216" cy="420624"/>
+            <a:off x="7717536" y="4224528"/>
+            <a:ext cx="1737360" cy="493776"/>
           </a:xfrm>
           <a:prstGeom prst="rect">
             <a:avLst/>
@@ -3012,14 +3012,28 @@
               <a:buNone/>
             </a:pPr>
             <a:r>
-              <a:rPr lang="en-US" sz="1300" b="1" dirty="0">
+              <a:rPr lang="en-US" sz="1200" b="1" dirty="0">
                 <a:solidFill>
                   <a:schemeClr val="bg1"/>
                 </a:solidFill>
               </a:rPr>
-              <a:t>AX진단 + Agent 실증</a:t>
-            </a:r>
-            <a:endParaRPr lang="en-US" sz="1300" dirty="0"/>
+              <a:t>AX 과제 Pool 확보</a:t>
+            </a:r>
+            <a:endParaRPr lang="en-US" sz="1200" dirty="0"/>
+          </a:p>
+          <a:p>
+            <a:pPr algn="ctr" indent="0" marL="0">
+              <a:buNone/>
+            </a:pPr>
+            <a:r>
+              <a:rPr lang="en-US" sz="900" dirty="0">
+                <a:solidFill>
+                  <a:schemeClr val="bg1"/>
+                </a:solidFill>
+              </a:rPr>
+              <a:t>적합성·가용성·실현성 검증</a:t>
+            </a:r>
+            <a:endParaRPr lang="en-US" sz="1200" dirty="0"/>
           </a:p>
         </p:txBody>
       </p:sp>
@@ -3031,7 +3045,7 @@
         </p:nvSpPr>
         <p:spPr>
           <a:xfrm rot="5400000">
-            <a:off x="9518904" y="4224528"/>
+            <a:off x="9491472" y="4297680"/>
             <a:ext cx="274320" cy="164592"/>
           </a:xfrm>
           <a:prstGeom prst="triangle">
@@ -3051,8 +3065,8 @@
         </p:nvSpPr>
         <p:spPr>
           <a:xfrm>
-            <a:off x="9820656" y="4059936"/>
-            <a:ext cx="1737360" cy="603504"/>
+            <a:off x="9784080" y="4041648"/>
+            <a:ext cx="1810512" cy="676656"/>
           </a:xfrm>
           <a:prstGeom prst="rect">
             <a:avLst/>
@@ -3076,8 +3090,8 @@
         </p:nvSpPr>
         <p:spPr>
           <a:xfrm>
-            <a:off x="9820656" y="4059936"/>
-            <a:ext cx="685800" cy="182880"/>
+            <a:off x="9784080" y="4041648"/>
+            <a:ext cx="566928" cy="182880"/>
           </a:xfrm>
           <a:prstGeom prst="rect">
             <a:avLst/>
@@ -3096,8 +3110,8 @@
         </p:nvSpPr>
         <p:spPr>
           <a:xfrm>
-            <a:off x="9820656" y="4059936"/>
-            <a:ext cx="685800" cy="182880"/>
+            <a:off x="9784080" y="4041648"/>
+            <a:ext cx="566928" cy="182880"/>
           </a:xfrm>
           <a:prstGeom prst="rect">
             <a:avLst/>
@@ -3118,7 +3132,7 @@
                   <a:schemeClr val="bg1"/>
                 </a:solidFill>
               </a:rPr>
-              <a:t>기대효과</a:t>
+              <a:t>사업</a:t>
             </a:r>
             <a:endParaRPr lang="en-US" sz="900" dirty="0"/>
           </a:p>
@@ -3132,8 +3146,8 @@
         </p:nvSpPr>
         <p:spPr>
           <a:xfrm>
-            <a:off x="9893808" y="4242816"/>
-            <a:ext cx="1591056" cy="420624"/>
+            <a:off x="9838944" y="4224528"/>
+            <a:ext cx="1700784" cy="493776"/>
           </a:xfrm>
           <a:prstGeom prst="rect">
             <a:avLst/>
@@ -3154,65 +3168,29 @@
                   <a:schemeClr val="accent3"/>
                 </a:solidFill>
               </a:rPr>
-              <a:t>효과 실증 → 사업 범위 확정</a:t>
+              <a:t>사업부 본사업 연계</a:t>
             </a:r>
             <a:endParaRPr lang="en-US" sz="1200" dirty="0"/>
           </a:p>
-        </p:txBody>
-      </p:sp>
-      <p:sp>
-        <p:nvSpPr>
-          <p:cNvPr id="67" name="Text 65"/>
-          <p:cNvSpPr txBox="1"/>
-          <p:nvPr/>
-        </p:nvSpPr>
-        <p:spPr>
-          <a:xfrm>
-            <a:off x="7498080" y="4672584"/>
-            <a:ext cx="2194560" cy="274320"/>
-          </a:xfrm>
-          <a:prstGeom prst="rect">
-            <a:avLst/>
-          </a:prstGeom>
-          <a:noFill/>
-          <a:ln/>
-        </p:spPr>
-        <p:txBody>
-          <a:bodyPr wrap="square" lIns="0" tIns="0" rIns="0" bIns="0" rtlCol="0" anchor="ctr"/>
-          <a:lstStyle/>
-          <a:p>
-            <a:pPr algn="ctr" indent="0" marL="0">
-              <a:buNone/>
-            </a:pPr>
-            <a:r>
-              <a:rPr lang="en-US" sz="850" dirty="0">
-                <a:solidFill>
-                  <a:schemeClr val="accent5"/>
-                </a:solidFill>
-              </a:rPr>
-              <a:t>※ 실데이터·시스템 진단 /</a:t>
-            </a:r>
-            <a:endParaRPr lang="en-US" sz="850" dirty="0"/>
-          </a:p>
-          <a:p>
-            <a:pPr algn="ctr" indent="0" marL="0">
-              <a:buNone/>
-            </a:pPr>
-            <a:r>
-              <a:rPr lang="en-US" sz="850" dirty="0">
-                <a:solidFill>
-                  <a:schemeClr val="accent5"/>
-                </a:solidFill>
-              </a:rPr>
-              <a:t>레터 발송 Agent 실구현</a:t>
-            </a:r>
-            <a:endParaRPr lang="en-US" sz="850" dirty="0"/>
-          </a:p>
-        </p:txBody>
-      </p:sp>
-      <p:sp>
-        <p:nvSpPr>
-          <p:cNvPr id="68" name="row-label-3"/>
+          <a:p>
+            <a:pPr algn="ctr" indent="0" marL="0">
+              <a:buNone/>
+            </a:pPr>
+            <a:r>
+              <a:rPr lang="en-US" sz="900" dirty="0">
+                <a:solidFill>
+                  <a:schemeClr val="tx2"/>
+                </a:solidFill>
+              </a:rPr>
+              <a:t>AX진단 → AX-PI / Quick-Win</a:t>
+            </a:r>
+            <a:endParaRPr lang="en-US" sz="1200" dirty="0"/>
+          </a:p>
+        </p:txBody>
+      </p:sp>
+      <p:sp>
+        <p:nvSpPr>
+          <p:cNvPr id="67" name="row-label-3"/>
           <p:cNvSpPr/>
           <p:nvPr/>
         </p:nvSpPr>
@@ -3225,7 +3203,7 @@
             <a:avLst/>
           </a:prstGeom>
           <a:solidFill>
-            <a:schemeClr val="bg1"/>
+            <a:schemeClr val="bg2"/>
           </a:solidFill>
           <a:ln w="9525">
             <a:solidFill>
@@ -3237,7 +3215,7 @@
       </p:sp>
       <p:sp>
         <p:nvSpPr>
-          <p:cNvPr id="69" name="Text 67"/>
+          <p:cNvPr id="68" name="Text 66"/>
           <p:cNvSpPr txBox="1"/>
           <p:nvPr/>
         </p:nvSpPr>
@@ -3265,7 +3243,7 @@
                   <a:schemeClr val="tx1"/>
                 </a:solidFill>
               </a:rPr>
-              <a:t>AX-PI</a:t>
+              <a:t>세부운영</a:t>
             </a:r>
             <a:endParaRPr lang="en-US" sz="1300" dirty="0"/>
           </a:p>
@@ -3279,7 +3257,7 @@
                   <a:schemeClr val="tx1"/>
                 </a:solidFill>
               </a:rPr>
-              <a:t>사업 연계</a:t>
+              <a:t>계획</a:t>
             </a:r>
             <a:endParaRPr lang="en-US" sz="1300" dirty="0"/>
           </a:p>
@@ -3288,14 +3266,86 @@
               <a:buNone/>
             </a:pPr>
             <a:r>
-              <a:rPr lang="en-US" sz="950" dirty="0">
+              <a:rPr lang="en-US" sz="1300" b="1" dirty="0">
+                <a:solidFill>
+                  <a:schemeClr val="tx1"/>
+                </a:solidFill>
+              </a:rPr>
+              <a:t>(e.g.</a:t>
+            </a:r>
+            <a:endParaRPr lang="en-US" sz="1300" dirty="0"/>
+          </a:p>
+          <a:p>
+            <a:pPr algn="ctr" indent="0" marL="0">
+              <a:buNone/>
+            </a:pPr>
+            <a:r>
+              <a:rPr lang="en-US" sz="1300" b="1" dirty="0">
+                <a:solidFill>
+                  <a:schemeClr val="tx1"/>
+                </a:solidFill>
+              </a:rPr>
+              <a:t>백화점)</a:t>
+            </a:r>
+            <a:endParaRPr lang="en-US" sz="1300" dirty="0"/>
+          </a:p>
+        </p:txBody>
+      </p:sp>
+      <p:sp>
+        <p:nvSpPr>
+          <p:cNvPr id="69" name="Text 67"/>
+          <p:cNvSpPr txBox="1"/>
+          <p:nvPr/>
+        </p:nvSpPr>
+        <p:spPr>
+          <a:xfrm>
+            <a:off x="5559552" y="5074920"/>
+            <a:ext cx="6035040" cy="274320"/>
+          </a:xfrm>
+          <a:prstGeom prst="rect">
+            <a:avLst/>
+          </a:prstGeom>
+          <a:noFill/>
+          <a:ln/>
+        </p:spPr>
+        <p:txBody>
+          <a:bodyPr wrap="square" lIns="0" tIns="0" rIns="0" bIns="0" rtlCol="0" anchor="ctr"/>
+          <a:lstStyle/>
+          <a:p>
+            <a:pPr indent="0" marL="0">
+              <a:buNone/>
+            </a:pPr>
+            <a:r>
+              <a:rPr lang="en-US" sz="1250" dirty="0">
                 <a:solidFill>
                   <a:schemeClr val="accent5"/>
                 </a:solidFill>
               </a:rPr>
-              <a:t>'27</a:t>
-            </a:r>
-            <a:endParaRPr lang="en-US" sz="1300" dirty="0"/>
+              <a:t>• </a:t>
+            </a:r>
+            <a:pPr indent="0" marL="0">
+              <a:buNone/>
+            </a:pPr>
+            <a:r>
+              <a:rPr lang="en-US" sz="1250" b="1" dirty="0">
+                <a:solidFill>
+                  <a:schemeClr val="tx1"/>
+                </a:solidFill>
+              </a:rPr>
+              <a:t>Inno-Camp 결과를 </a:t>
+            </a:r>
+            <a:pPr indent="0" marL="0">
+              <a:buNone/>
+            </a:pPr>
+            <a:r>
+              <a:rPr lang="en-US" sz="1250" b="1" dirty="0">
+                <a:solidFill>
+                  <a:schemeClr val="accent3"/>
+                </a:solidFill>
+              </a:rPr>
+              <a:t>사업부 '27 온/오프 통합 e커머스 구축으로 연계</a:t>
+            </a:r>
+            <a:endParaRPr lang="en-US" sz="1250" dirty="0"/>
           </a:p>
         </p:txBody>
       </p:sp>
@@ -3307,8 +3357,8 @@
         </p:nvSpPr>
         <p:spPr>
           <a:xfrm>
-            <a:off x="5559552" y="5074920"/>
-            <a:ext cx="5989320" cy="274320"/>
+            <a:off x="5715000" y="5340096"/>
+            <a:ext cx="5897880" cy="237744"/>
           </a:xfrm>
           <a:prstGeom prst="rect">
             <a:avLst/>
@@ -3323,96 +3373,30 @@
             <a:pPr indent="0" marL="0">
               <a:buNone/>
             </a:pPr>
-            <a:r>
-              <a:rPr lang="en-US" sz="1250" dirty="0">
-                <a:solidFill>
-                  <a:schemeClr val="accent5"/>
-                </a:solidFill>
-              </a:rPr>
-              <a:t>• </a:t>
-            </a:r>
-            <a:pPr indent="0" marL="0">
-              <a:buNone/>
-            </a:pPr>
-            <a:r>
-              <a:rPr lang="en-US" sz="1250" b="1" dirty="0">
-                <a:solidFill>
-                  <a:schemeClr val="tx1"/>
-                </a:solidFill>
-              </a:rPr>
-              <a:t>구축 범위·요건 불명확 → </a:t>
-            </a:r>
-            <a:pPr indent="0" marL="0">
-              <a:buNone/>
-            </a:pPr>
-            <a:r>
-              <a:rPr lang="en-US" sz="1250" b="1" dirty="0">
-                <a:solidFill>
-                  <a:schemeClr val="accent3"/>
-                </a:solidFill>
-              </a:rPr>
-              <a:t>AX-PI로 To-Be·요건 정의, 사업부 본사업 연계</a:t>
-            </a:r>
-            <a:endParaRPr lang="en-US" sz="1250" dirty="0"/>
-          </a:p>
-        </p:txBody>
-      </p:sp>
-      <p:sp>
-        <p:nvSpPr>
-          <p:cNvPr id="71" name="Text 69"/>
-          <p:cNvSpPr txBox="1"/>
-          <p:nvPr/>
-        </p:nvSpPr>
-        <p:spPr>
-          <a:xfrm>
-            <a:off x="5715000" y="5349240"/>
-            <a:ext cx="5852160" cy="237744"/>
-          </a:xfrm>
-          <a:prstGeom prst="rect">
-            <a:avLst/>
-          </a:prstGeom>
-          <a:noFill/>
-          <a:ln/>
-        </p:spPr>
-        <p:txBody>
-          <a:bodyPr wrap="square" lIns="0" tIns="0" rIns="0" bIns="0" rtlCol="0" anchor="ctr"/>
-          <a:lstStyle/>
-          <a:p>
-            <a:pPr indent="0" marL="0">
-              <a:buNone/>
-            </a:pPr>
-            <a:r>
-              <a:rPr lang="en-US" sz="1050" dirty="0">
-                <a:solidFill>
-                  <a:schemeClr val="accent5"/>
-                </a:solidFill>
-              </a:rPr>
-              <a:t>e.g. '27 AI 기반 온/오프 통합 e커머스 서비스 구축(사업부 수행) 범위 선점</a:t>
-            </a:r>
             <a:endParaRPr lang="en-US" sz="1050" dirty="0"/>
           </a:p>
         </p:txBody>
       </p:sp>
       <p:sp>
         <p:nvSpPr>
-          <p:cNvPr id="72" name="Shape 70"/>
+          <p:cNvPr id="71" name="plan-step-1"/>
           <p:cNvSpPr/>
           <p:nvPr/>
         </p:nvSpPr>
         <p:spPr>
           <a:xfrm>
-            <a:off x="5577840" y="5641848"/>
-            <a:ext cx="1783080" cy="603504"/>
-          </a:xfrm>
-          <a:prstGeom prst="rect">
-            <a:avLst/>
-          </a:prstGeom>
-          <a:solidFill>
-            <a:schemeClr val="bg2"/>
-          </a:solidFill>
-          <a:ln w="9525">
+            <a:off x="5577840" y="5385816"/>
+            <a:ext cx="1280160" cy="530352"/>
+          </a:xfrm>
+          <a:prstGeom prst="homePlate">
+            <a:avLst/>
+          </a:prstGeom>
+          <a:solidFill>
+            <a:schemeClr val="accent4"/>
+          </a:solidFill>
+          <a:ln w="12700">
             <a:solidFill>
-              <a:schemeClr val="accent6"/>
+              <a:srgbClr val="FFFFFF"/>
             </a:solidFill>
             <a:prstDash val="solid"/>
           </a:ln>
@@ -3420,136 +3404,110 @@
       </p:sp>
       <p:sp>
         <p:nvSpPr>
-          <p:cNvPr id="73" name="Shape 71"/>
+          <p:cNvPr id="72" name="Text 70"/>
+          <p:cNvSpPr txBox="1"/>
+          <p:nvPr/>
+        </p:nvSpPr>
+        <p:spPr>
+          <a:xfrm>
+            <a:off x="5623560" y="5385816"/>
+            <a:ext cx="1051560" cy="530352"/>
+          </a:xfrm>
+          <a:prstGeom prst="rect">
+            <a:avLst/>
+          </a:prstGeom>
+          <a:noFill/>
+          <a:ln/>
+        </p:spPr>
+        <p:txBody>
+          <a:bodyPr wrap="square" lIns="0" tIns="0" rIns="0" bIns="0" rtlCol="0" anchor="ctr"/>
+          <a:lstStyle/>
+          <a:p>
+            <a:pPr algn="ctr" indent="0" marL="0">
+              <a:buNone/>
+            </a:pPr>
+            <a:r>
+              <a:rPr lang="en-US" sz="950" b="1" dirty="0">
+                <a:solidFill>
+                  <a:schemeClr val="tx1"/>
+                </a:solidFill>
+              </a:rPr>
+              <a:t>과정 설계·준비</a:t>
+            </a:r>
+            <a:endParaRPr lang="en-US" sz="950" dirty="0"/>
+          </a:p>
+          <a:p>
+            <a:pPr algn="ctr" indent="0" marL="0">
+              <a:buNone/>
+            </a:pPr>
+            <a:r>
+              <a:rPr lang="en-US" sz="850" dirty="0">
+                <a:solidFill>
+                  <a:schemeClr val="tx1"/>
+                </a:solidFill>
+              </a:rPr>
+              <a:t>'26.10</a:t>
+            </a:r>
+            <a:endParaRPr lang="en-US" sz="950" dirty="0"/>
+          </a:p>
+        </p:txBody>
+      </p:sp>
+      <p:sp>
+        <p:nvSpPr>
+          <p:cNvPr id="73" name="Text 71"/>
+          <p:cNvSpPr txBox="1"/>
+          <p:nvPr/>
+        </p:nvSpPr>
+        <p:spPr>
+          <a:xfrm>
+            <a:off x="5669280" y="5952744"/>
+            <a:ext cx="1097280" cy="329184"/>
+          </a:xfrm>
+          <a:prstGeom prst="rect">
+            <a:avLst/>
+          </a:prstGeom>
+          <a:noFill/>
+          <a:ln/>
+        </p:spPr>
+        <p:txBody>
+          <a:bodyPr wrap="square" lIns="0" tIns="0" rIns="0" bIns="0" rtlCol="0" anchor="t"/>
+          <a:lstStyle/>
+          <a:p>
+            <a:pPr algn="ctr" indent="0" marL="0">
+              <a:buNone/>
+            </a:pPr>
+            <a:r>
+              <a:rPr lang="en-US" sz="900" dirty="0">
+                <a:solidFill>
+                  <a:schemeClr val="tx2"/>
+                </a:solidFill>
+              </a:rPr>
+              <a:t>데이터셋 6종·실습 시나리오</a:t>
+            </a:r>
+            <a:endParaRPr lang="en-US" sz="900" dirty="0"/>
+          </a:p>
+        </p:txBody>
+      </p:sp>
+      <p:sp>
+        <p:nvSpPr>
+          <p:cNvPr id="74" name="plan-step-2"/>
           <p:cNvSpPr/>
           <p:nvPr/>
         </p:nvSpPr>
         <p:spPr>
           <a:xfrm>
-            <a:off x="5577840" y="5641848"/>
-            <a:ext cx="685800" cy="182880"/>
-          </a:xfrm>
-          <a:prstGeom prst="rect">
-            <a:avLst/>
-          </a:prstGeom>
-          <a:solidFill>
-            <a:schemeClr val="accent5"/>
-          </a:solidFill>
-          <a:ln/>
-        </p:spPr>
-      </p:sp>
-      <p:sp>
-        <p:nvSpPr>
-          <p:cNvPr id="74" name="Text 72"/>
-          <p:cNvSpPr txBox="1"/>
-          <p:nvPr/>
-        </p:nvSpPr>
-        <p:spPr>
-          <a:xfrm>
-            <a:off x="5577840" y="5641848"/>
-            <a:ext cx="685800" cy="182880"/>
-          </a:xfrm>
-          <a:prstGeom prst="rect">
-            <a:avLst/>
-          </a:prstGeom>
-          <a:noFill/>
-          <a:ln/>
-        </p:spPr>
-        <p:txBody>
-          <a:bodyPr wrap="square" lIns="0" tIns="0" rIns="0" bIns="0" rtlCol="0" anchor="ctr"/>
-          <a:lstStyle/>
-          <a:p>
-            <a:pPr algn="ctr" indent="0" marL="0">
-              <a:buNone/>
-            </a:pPr>
-            <a:r>
-              <a:rPr lang="en-US" sz="900" b="1" dirty="0">
-                <a:solidFill>
-                  <a:schemeClr val="bg1"/>
-                </a:solidFill>
-              </a:rPr>
-              <a:t>이슈</a:t>
-            </a:r>
-            <a:endParaRPr lang="en-US" sz="900" dirty="0"/>
-          </a:p>
-        </p:txBody>
-      </p:sp>
-      <p:sp>
-        <p:nvSpPr>
-          <p:cNvPr id="75" name="Text 73"/>
-          <p:cNvSpPr txBox="1"/>
-          <p:nvPr/>
-        </p:nvSpPr>
-        <p:spPr>
-          <a:xfrm>
-            <a:off x="5650992" y="5824728"/>
-            <a:ext cx="1636776" cy="420624"/>
-          </a:xfrm>
-          <a:prstGeom prst="rect">
-            <a:avLst/>
-          </a:prstGeom>
-          <a:noFill/>
-          <a:ln/>
-        </p:spPr>
-        <p:txBody>
-          <a:bodyPr wrap="square" lIns="0" tIns="0" rIns="0" bIns="0" rtlCol="0" anchor="ctr"/>
-          <a:lstStyle/>
-          <a:p>
-            <a:pPr algn="ctr" indent="0" marL="0">
-              <a:buNone/>
-            </a:pPr>
-            <a:r>
-              <a:rPr lang="en-US" sz="1200" b="1" dirty="0">
-                <a:solidFill>
-                  <a:schemeClr val="tx2"/>
-                </a:solidFill>
-              </a:rPr>
-              <a:t>온/오프 고객 데이터·여정 단절</a:t>
-            </a:r>
-            <a:endParaRPr lang="en-US" sz="1200" dirty="0"/>
-          </a:p>
-        </p:txBody>
-      </p:sp>
-      <p:sp>
-        <p:nvSpPr>
-          <p:cNvPr id="76" name="Shape 74"/>
-          <p:cNvSpPr/>
-          <p:nvPr/>
-        </p:nvSpPr>
-        <p:spPr>
-          <a:xfrm rot="5400000">
-            <a:off x="7351776" y="5806440"/>
-            <a:ext cx="274320" cy="164592"/>
-          </a:xfrm>
-          <a:prstGeom prst="triangle">
-            <a:avLst/>
-          </a:prstGeom>
-          <a:solidFill>
-            <a:schemeClr val="accent6"/>
-          </a:solidFill>
-          <a:ln/>
-        </p:spPr>
-      </p:sp>
-      <p:sp>
-        <p:nvSpPr>
-          <p:cNvPr id="77" name="Shape 75"/>
-          <p:cNvSpPr/>
-          <p:nvPr/>
-        </p:nvSpPr>
-        <p:spPr>
-          <a:xfrm>
-            <a:off x="7653528" y="5641848"/>
-            <a:ext cx="1874520" cy="603504"/>
-          </a:xfrm>
-          <a:prstGeom prst="rect">
+            <a:off x="6766560" y="5385816"/>
+            <a:ext cx="1280160" cy="530352"/>
+          </a:xfrm>
+          <a:prstGeom prst="chevron">
             <a:avLst/>
           </a:prstGeom>
           <a:solidFill>
             <a:schemeClr val="accent1"/>
           </a:solidFill>
-          <a:ln w="9525">
+          <a:ln w="12700">
             <a:solidFill>
-              <a:schemeClr val="accent1"/>
+              <a:srgbClr val="FFFFFF"/>
             </a:solidFill>
             <a:prstDash val="solid"/>
           </a:ln>
@@ -3557,136 +3515,110 @@
       </p:sp>
       <p:sp>
         <p:nvSpPr>
-          <p:cNvPr id="78" name="Shape 76"/>
+          <p:cNvPr id="75" name="Text 73"/>
+          <p:cNvSpPr txBox="1"/>
+          <p:nvPr/>
+        </p:nvSpPr>
+        <p:spPr>
+          <a:xfrm>
+            <a:off x="6949440" y="5385816"/>
+            <a:ext cx="914400" cy="530352"/>
+          </a:xfrm>
+          <a:prstGeom prst="rect">
+            <a:avLst/>
+          </a:prstGeom>
+          <a:noFill/>
+          <a:ln/>
+        </p:spPr>
+        <p:txBody>
+          <a:bodyPr wrap="square" lIns="0" tIns="0" rIns="0" bIns="0" rtlCol="0" anchor="ctr"/>
+          <a:lstStyle/>
+          <a:p>
+            <a:pPr algn="ctr" indent="0" marL="0">
+              <a:buNone/>
+            </a:pPr>
+            <a:r>
+              <a:rPr lang="en-US" sz="950" b="1" dirty="0">
+                <a:solidFill>
+                  <a:schemeClr val="bg1"/>
+                </a:solidFill>
+              </a:rPr>
+              <a:t>Camp 운영</a:t>
+            </a:r>
+            <a:endParaRPr lang="en-US" sz="950" dirty="0"/>
+          </a:p>
+          <a:p>
+            <a:pPr algn="ctr" indent="0" marL="0">
+              <a:buNone/>
+            </a:pPr>
+            <a:r>
+              <a:rPr lang="en-US" sz="850" dirty="0">
+                <a:solidFill>
+                  <a:schemeClr val="bg1"/>
+                </a:solidFill>
+              </a:rPr>
+              <a:t>'26.10.30 ✓</a:t>
+            </a:r>
+            <a:endParaRPr lang="en-US" sz="950" dirty="0"/>
+          </a:p>
+        </p:txBody>
+      </p:sp>
+      <p:sp>
+        <p:nvSpPr>
+          <p:cNvPr id="76" name="Text 74"/>
+          <p:cNvSpPr txBox="1"/>
+          <p:nvPr/>
+        </p:nvSpPr>
+        <p:spPr>
+          <a:xfrm>
+            <a:off x="6858000" y="5952744"/>
+            <a:ext cx="1097280" cy="329184"/>
+          </a:xfrm>
+          <a:prstGeom prst="rect">
+            <a:avLst/>
+          </a:prstGeom>
+          <a:noFill/>
+          <a:ln/>
+        </p:spPr>
+        <p:txBody>
+          <a:bodyPr wrap="square" lIns="0" tIns="0" rIns="0" bIns="0" rtlCol="0" anchor="t"/>
+          <a:lstStyle/>
+          <a:p>
+            <a:pPr algn="ctr" indent="0" marL="0">
+              <a:buNone/>
+            </a:pPr>
+            <a:r>
+              <a:rPr lang="en-US" sz="900" dirty="0">
+                <a:solidFill>
+                  <a:schemeClr val="tx2"/>
+                </a:solidFill>
+              </a:rPr>
+              <a:t>분석 → 기획 → 구현 실습</a:t>
+            </a:r>
+            <a:endParaRPr lang="en-US" sz="900" dirty="0"/>
+          </a:p>
+        </p:txBody>
+      </p:sp>
+      <p:sp>
+        <p:nvSpPr>
+          <p:cNvPr id="77" name="plan-step-3"/>
           <p:cNvSpPr/>
           <p:nvPr/>
         </p:nvSpPr>
         <p:spPr>
           <a:xfrm>
-            <a:off x="7653528" y="5641848"/>
-            <a:ext cx="685800" cy="182880"/>
-          </a:xfrm>
-          <a:prstGeom prst="rect">
-            <a:avLst/>
-          </a:prstGeom>
-          <a:solidFill>
-            <a:schemeClr val="tx2"/>
-          </a:solidFill>
-          <a:ln/>
-        </p:spPr>
-      </p:sp>
-      <p:sp>
-        <p:nvSpPr>
-          <p:cNvPr id="79" name="Text 77"/>
-          <p:cNvSpPr txBox="1"/>
-          <p:nvPr/>
-        </p:nvSpPr>
-        <p:spPr>
-          <a:xfrm>
-            <a:off x="7653528" y="5641848"/>
-            <a:ext cx="685800" cy="182880"/>
-          </a:xfrm>
-          <a:prstGeom prst="rect">
-            <a:avLst/>
-          </a:prstGeom>
-          <a:noFill/>
-          <a:ln/>
-        </p:spPr>
-        <p:txBody>
-          <a:bodyPr wrap="square" lIns="0" tIns="0" rIns="0" bIns="0" rtlCol="0" anchor="ctr"/>
-          <a:lstStyle/>
-          <a:p>
-            <a:pPr algn="ctr" indent="0" marL="0">
-              <a:buNone/>
-            </a:pPr>
-            <a:r>
-              <a:rPr lang="en-US" sz="900" b="1" dirty="0">
-                <a:solidFill>
-                  <a:schemeClr val="bg1"/>
-                </a:solidFill>
-              </a:rPr>
-              <a:t>AX 활동</a:t>
-            </a:r>
-            <a:endParaRPr lang="en-US" sz="900" dirty="0"/>
-          </a:p>
-        </p:txBody>
-      </p:sp>
-      <p:sp>
-        <p:nvSpPr>
-          <p:cNvPr id="80" name="Text 78"/>
-          <p:cNvSpPr txBox="1"/>
-          <p:nvPr/>
-        </p:nvSpPr>
-        <p:spPr>
-          <a:xfrm>
-            <a:off x="7726680" y="5824728"/>
-            <a:ext cx="1728216" cy="420624"/>
-          </a:xfrm>
-          <a:prstGeom prst="rect">
-            <a:avLst/>
-          </a:prstGeom>
-          <a:noFill/>
-          <a:ln/>
-        </p:spPr>
-        <p:txBody>
-          <a:bodyPr wrap="square" lIns="0" tIns="0" rIns="0" bIns="0" rtlCol="0" anchor="ctr"/>
-          <a:lstStyle/>
-          <a:p>
-            <a:pPr algn="ctr" indent="0" marL="0">
-              <a:buNone/>
-            </a:pPr>
-            <a:r>
-              <a:rPr lang="en-US" sz="1300" b="1" dirty="0">
-                <a:solidFill>
-                  <a:schemeClr val="bg1"/>
-                </a:solidFill>
-              </a:rPr>
-              <a:t>AX-PI (To-Be 설계)</a:t>
-            </a:r>
-            <a:endParaRPr lang="en-US" sz="1300" dirty="0"/>
-          </a:p>
-        </p:txBody>
-      </p:sp>
-      <p:sp>
-        <p:nvSpPr>
-          <p:cNvPr id="81" name="Shape 79"/>
-          <p:cNvSpPr/>
-          <p:nvPr/>
-        </p:nvSpPr>
-        <p:spPr>
-          <a:xfrm rot="5400000">
-            <a:off x="9518904" y="5806440"/>
-            <a:ext cx="274320" cy="164592"/>
-          </a:xfrm>
-          <a:prstGeom prst="triangle">
-            <a:avLst/>
-          </a:prstGeom>
-          <a:solidFill>
-            <a:schemeClr val="accent6"/>
-          </a:solidFill>
-          <a:ln/>
-        </p:spPr>
-      </p:sp>
-      <p:sp>
-        <p:nvSpPr>
-          <p:cNvPr id="82" name="Shape 80"/>
-          <p:cNvSpPr/>
-          <p:nvPr/>
-        </p:nvSpPr>
-        <p:spPr>
-          <a:xfrm>
-            <a:off x="9820656" y="5641848"/>
-            <a:ext cx="1737360" cy="603504"/>
-          </a:xfrm>
-          <a:prstGeom prst="rect">
-            <a:avLst/>
-          </a:prstGeom>
-          <a:solidFill>
-            <a:schemeClr val="bg2"/>
-          </a:solidFill>
-          <a:ln w="9525">
+            <a:off x="7955280" y="5385816"/>
+            <a:ext cx="1280160" cy="530352"/>
+          </a:xfrm>
+          <a:prstGeom prst="chevron">
+            <a:avLst/>
+          </a:prstGeom>
+          <a:solidFill>
+            <a:schemeClr val="accent4"/>
+          </a:solidFill>
+          <a:ln w="12700">
             <a:solidFill>
-              <a:schemeClr val="accent6"/>
+              <a:srgbClr val="FFFFFF"/>
             </a:solidFill>
             <a:prstDash val="solid"/>
           </a:ln>
@@ -3694,164 +3626,110 @@
       </p:sp>
       <p:sp>
         <p:nvSpPr>
-          <p:cNvPr id="83" name="Shape 81"/>
+          <p:cNvPr id="78" name="Text 76"/>
+          <p:cNvSpPr txBox="1"/>
+          <p:nvPr/>
+        </p:nvSpPr>
+        <p:spPr>
+          <a:xfrm>
+            <a:off x="8138160" y="5385816"/>
+            <a:ext cx="914400" cy="530352"/>
+          </a:xfrm>
+          <a:prstGeom prst="rect">
+            <a:avLst/>
+          </a:prstGeom>
+          <a:noFill/>
+          <a:ln/>
+        </p:spPr>
+        <p:txBody>
+          <a:bodyPr wrap="square" lIns="0" tIns="0" rIns="0" bIns="0" rtlCol="0" anchor="ctr"/>
+          <a:lstStyle/>
+          <a:p>
+            <a:pPr algn="ctr" indent="0" marL="0">
+              <a:buNone/>
+            </a:pPr>
+            <a:r>
+              <a:rPr lang="en-US" sz="950" b="1" dirty="0">
+                <a:solidFill>
+                  <a:schemeClr val="tx1"/>
+                </a:solidFill>
+              </a:rPr>
+              <a:t>결과 정리·진단 제안</a:t>
+            </a:r>
+            <a:endParaRPr lang="en-US" sz="950" dirty="0"/>
+          </a:p>
+          <a:p>
+            <a:pPr algn="ctr" indent="0" marL="0">
+              <a:buNone/>
+            </a:pPr>
+            <a:r>
+              <a:rPr lang="en-US" sz="850" dirty="0">
+                <a:solidFill>
+                  <a:schemeClr val="tx1"/>
+                </a:solidFill>
+              </a:rPr>
+              <a:t>'26.11</a:t>
+            </a:r>
+            <a:endParaRPr lang="en-US" sz="950" dirty="0"/>
+          </a:p>
+        </p:txBody>
+      </p:sp>
+      <p:sp>
+        <p:nvSpPr>
+          <p:cNvPr id="79" name="Text 77"/>
+          <p:cNvSpPr txBox="1"/>
+          <p:nvPr/>
+        </p:nvSpPr>
+        <p:spPr>
+          <a:xfrm>
+            <a:off x="8046720" y="5952744"/>
+            <a:ext cx="1097280" cy="329184"/>
+          </a:xfrm>
+          <a:prstGeom prst="rect">
+            <a:avLst/>
+          </a:prstGeom>
+          <a:noFill/>
+          <a:ln/>
+        </p:spPr>
+        <p:txBody>
+          <a:bodyPr wrap="square" lIns="0" tIns="0" rIns="0" bIns="0" rtlCol="0" anchor="t"/>
+          <a:lstStyle/>
+          <a:p>
+            <a:pPr algn="ctr" indent="0" marL="0">
+              <a:buNone/>
+            </a:pPr>
+            <a:r>
+              <a:rPr lang="en-US" sz="900" dirty="0">
+                <a:solidFill>
+                  <a:schemeClr val="tx2"/>
+                </a:solidFill>
+              </a:rPr>
+              <a:t>과제 리스트·진단 제안서</a:t>
+            </a:r>
+            <a:endParaRPr lang="en-US" sz="900" dirty="0"/>
+          </a:p>
+        </p:txBody>
+      </p:sp>
+      <p:sp>
+        <p:nvSpPr>
+          <p:cNvPr id="80" name="plan-step-4"/>
           <p:cNvSpPr/>
           <p:nvPr/>
         </p:nvSpPr>
         <p:spPr>
           <a:xfrm>
-            <a:off x="9820656" y="5641848"/>
-            <a:ext cx="685800" cy="182880"/>
-          </a:xfrm>
-          <a:prstGeom prst="rect">
-            <a:avLst/>
-          </a:prstGeom>
-          <a:solidFill>
-            <a:schemeClr val="accent5"/>
-          </a:solidFill>
-          <a:ln/>
-        </p:spPr>
-      </p:sp>
-      <p:sp>
-        <p:nvSpPr>
-          <p:cNvPr id="84" name="Text 82"/>
-          <p:cNvSpPr txBox="1"/>
-          <p:nvPr/>
-        </p:nvSpPr>
-        <p:spPr>
-          <a:xfrm>
-            <a:off x="9820656" y="5641848"/>
-            <a:ext cx="685800" cy="182880"/>
-          </a:xfrm>
-          <a:prstGeom prst="rect">
-            <a:avLst/>
-          </a:prstGeom>
-          <a:noFill/>
-          <a:ln/>
-        </p:spPr>
-        <p:txBody>
-          <a:bodyPr wrap="square" lIns="0" tIns="0" rIns="0" bIns="0" rtlCol="0" anchor="ctr"/>
-          <a:lstStyle/>
-          <a:p>
-            <a:pPr algn="ctr" indent="0" marL="0">
-              <a:buNone/>
-            </a:pPr>
-            <a:r>
-              <a:rPr lang="en-US" sz="900" b="1" dirty="0">
-                <a:solidFill>
-                  <a:schemeClr val="bg1"/>
-                </a:solidFill>
-              </a:rPr>
-              <a:t>기대효과</a:t>
-            </a:r>
-            <a:endParaRPr lang="en-US" sz="900" dirty="0"/>
-          </a:p>
-        </p:txBody>
-      </p:sp>
-      <p:sp>
-        <p:nvSpPr>
-          <p:cNvPr id="85" name="Text 83"/>
-          <p:cNvSpPr txBox="1"/>
-          <p:nvPr/>
-        </p:nvSpPr>
-        <p:spPr>
-          <a:xfrm>
-            <a:off x="9893808" y="5824728"/>
-            <a:ext cx="1591056" cy="420624"/>
-          </a:xfrm>
-          <a:prstGeom prst="rect">
-            <a:avLst/>
-          </a:prstGeom>
-          <a:noFill/>
-          <a:ln/>
-        </p:spPr>
-        <p:txBody>
-          <a:bodyPr wrap="square" lIns="0" tIns="0" rIns="0" bIns="0" rtlCol="0" anchor="ctr"/>
-          <a:lstStyle/>
-          <a:p>
-            <a:pPr algn="ctr" indent="0" marL="0">
-              <a:buNone/>
-            </a:pPr>
-            <a:r>
-              <a:rPr lang="en-US" sz="1200" b="1" dirty="0">
-                <a:solidFill>
-                  <a:schemeClr val="accent3"/>
-                </a:solidFill>
-              </a:rPr>
-              <a:t>사업부 구축 사업 수주 연계</a:t>
-            </a:r>
-            <a:endParaRPr lang="en-US" sz="1200" dirty="0"/>
-          </a:p>
-        </p:txBody>
-      </p:sp>
-      <p:sp>
-        <p:nvSpPr>
-          <p:cNvPr id="86" name="Text 84"/>
-          <p:cNvSpPr txBox="1"/>
-          <p:nvPr/>
-        </p:nvSpPr>
-        <p:spPr>
-          <a:xfrm>
-            <a:off x="7498080" y="6254496"/>
-            <a:ext cx="2194560" cy="274320"/>
-          </a:xfrm>
-          <a:prstGeom prst="rect">
-            <a:avLst/>
-          </a:prstGeom>
-          <a:noFill/>
-          <a:ln/>
-        </p:spPr>
-        <p:txBody>
-          <a:bodyPr wrap="square" lIns="0" tIns="0" rIns="0" bIns="0" rtlCol="0" anchor="ctr"/>
-          <a:lstStyle/>
-          <a:p>
-            <a:pPr algn="ctr" indent="0" marL="0">
-              <a:buNone/>
-            </a:pPr>
-            <a:r>
-              <a:rPr lang="en-US" sz="850" dirty="0">
-                <a:solidFill>
-                  <a:schemeClr val="accent5"/>
-                </a:solidFill>
-              </a:rPr>
-              <a:t>※ 통합 고객여정 To-Be / 구축 요건·</a:t>
-            </a:r>
-            <a:endParaRPr lang="en-US" sz="850" dirty="0"/>
-          </a:p>
-          <a:p>
-            <a:pPr algn="ctr" indent="0" marL="0">
-              <a:buNone/>
-            </a:pPr>
-            <a:r>
-              <a:rPr lang="en-US" sz="850" dirty="0">
-                <a:solidFill>
-                  <a:schemeClr val="accent5"/>
-                </a:solidFill>
-              </a:rPr>
-              <a:t>RFP 정의 → 사업부 이관</a:t>
-            </a:r>
-            <a:endParaRPr lang="en-US" sz="850" dirty="0"/>
-          </a:p>
-        </p:txBody>
-      </p:sp>
-      <p:sp>
-        <p:nvSpPr>
-          <p:cNvPr id="87" name="Shape 85"/>
-          <p:cNvSpPr/>
-          <p:nvPr/>
-        </p:nvSpPr>
-        <p:spPr>
-          <a:xfrm>
-            <a:off x="11558016" y="2779776"/>
-            <a:ext cx="128016" cy="0"/>
-          </a:xfrm>
-          <a:prstGeom prst="line">
-            <a:avLst/>
-          </a:prstGeom>
-          <a:noFill/>
-          <a:ln w="28575">
+            <a:off x="9144000" y="5385816"/>
+            <a:ext cx="1280160" cy="530352"/>
+          </a:xfrm>
+          <a:prstGeom prst="chevron">
+            <a:avLst/>
+          </a:prstGeom>
+          <a:solidFill>
+            <a:schemeClr val="accent4"/>
+          </a:solidFill>
+          <a:ln w="12700">
             <a:solidFill>
-              <a:schemeClr val="accent1"/>
+              <a:srgbClr val="FFFFFF"/>
             </a:solidFill>
             <a:prstDash val="solid"/>
           </a:ln>
@@ -3859,22 +3737,110 @@
       </p:sp>
       <p:sp>
         <p:nvSpPr>
-          <p:cNvPr id="88" name="Shape 86"/>
+          <p:cNvPr id="81" name="Text 79"/>
+          <p:cNvSpPr txBox="1"/>
+          <p:nvPr/>
+        </p:nvSpPr>
+        <p:spPr>
+          <a:xfrm>
+            <a:off x="9326880" y="5385816"/>
+            <a:ext cx="914400" cy="530352"/>
+          </a:xfrm>
+          <a:prstGeom prst="rect">
+            <a:avLst/>
+          </a:prstGeom>
+          <a:noFill/>
+          <a:ln/>
+        </p:spPr>
+        <p:txBody>
+          <a:bodyPr wrap="square" lIns="0" tIns="0" rIns="0" bIns="0" rtlCol="0" anchor="ctr"/>
+          <a:lstStyle/>
+          <a:p>
+            <a:pPr algn="ctr" indent="0" marL="0">
+              <a:buNone/>
+            </a:pPr>
+            <a:r>
+              <a:rPr lang="en-US" sz="950" b="1" dirty="0">
+                <a:solidFill>
+                  <a:schemeClr val="tx1"/>
+                </a:solidFill>
+              </a:rPr>
+              <a:t>진단·PI / QW</a:t>
+            </a:r>
+            <a:endParaRPr lang="en-US" sz="950" dirty="0"/>
+          </a:p>
+          <a:p>
+            <a:pPr algn="ctr" indent="0" marL="0">
+              <a:buNone/>
+            </a:pPr>
+            <a:r>
+              <a:rPr lang="en-US" sz="850" dirty="0">
+                <a:solidFill>
+                  <a:schemeClr val="tx1"/>
+                </a:solidFill>
+              </a:rPr>
+              <a:t>'26.4Q~'27.1H</a:t>
+            </a:r>
+            <a:endParaRPr lang="en-US" sz="950" dirty="0"/>
+          </a:p>
+        </p:txBody>
+      </p:sp>
+      <p:sp>
+        <p:nvSpPr>
+          <p:cNvPr id="82" name="Text 80"/>
+          <p:cNvSpPr txBox="1"/>
+          <p:nvPr/>
+        </p:nvSpPr>
+        <p:spPr>
+          <a:xfrm>
+            <a:off x="9235440" y="5952744"/>
+            <a:ext cx="1097280" cy="329184"/>
+          </a:xfrm>
+          <a:prstGeom prst="rect">
+            <a:avLst/>
+          </a:prstGeom>
+          <a:noFill/>
+          <a:ln/>
+        </p:spPr>
+        <p:txBody>
+          <a:bodyPr wrap="square" lIns="0" tIns="0" rIns="0" bIns="0" rtlCol="0" anchor="t"/>
+          <a:lstStyle/>
+          <a:p>
+            <a:pPr algn="ctr" indent="0" marL="0">
+              <a:buNone/>
+            </a:pPr>
+            <a:r>
+              <a:rPr lang="en-US" sz="900" dirty="0">
+                <a:solidFill>
+                  <a:schemeClr val="tx2"/>
+                </a:solidFill>
+              </a:rPr>
+              <a:t>To-Be·구축 요건, Agent 실증</a:t>
+            </a:r>
+            <a:endParaRPr lang="en-US" sz="900" dirty="0"/>
+          </a:p>
+        </p:txBody>
+      </p:sp>
+      <p:sp>
+        <p:nvSpPr>
+          <p:cNvPr id="83" name="plan-step-5"/>
           <p:cNvSpPr/>
           <p:nvPr/>
         </p:nvSpPr>
         <p:spPr>
           <a:xfrm>
-            <a:off x="11686032" y="2779776"/>
-            <a:ext cx="0" cy="3163824"/>
-          </a:xfrm>
-          <a:prstGeom prst="line">
-            <a:avLst/>
-          </a:prstGeom>
-          <a:noFill/>
-          <a:ln w="28575">
+            <a:off x="10332720" y="5385816"/>
+            <a:ext cx="1280160" cy="530352"/>
+          </a:xfrm>
+          <a:prstGeom prst="chevron">
+            <a:avLst/>
+          </a:prstGeom>
+          <a:solidFill>
+            <a:schemeClr val="accent5"/>
+          </a:solidFill>
+          <a:ln w="12700">
             <a:solidFill>
-              <a:schemeClr val="accent1"/>
+              <a:srgbClr val="FFFFFF"/>
             </a:solidFill>
             <a:prstDash val="solid"/>
           </a:ln>
@@ -3882,38 +3848,14 @@
       </p:sp>
       <p:sp>
         <p:nvSpPr>
-          <p:cNvPr id="89" name="Shape 87"/>
-          <p:cNvSpPr/>
-          <p:nvPr/>
-        </p:nvSpPr>
-        <p:spPr>
-          <a:xfrm>
-            <a:off x="11558016" y="5943600"/>
-            <a:ext cx="128016" cy="0"/>
-          </a:xfrm>
-          <a:prstGeom prst="line">
-            <a:avLst/>
-          </a:prstGeom>
-          <a:noFill/>
-          <a:ln w="28575">
-            <a:solidFill>
-              <a:schemeClr val="accent1"/>
-            </a:solidFill>
-            <a:prstDash val="solid"/>
-            <a:headEnd type="triangle"/>
-          </a:ln>
-        </p:spPr>
-      </p:sp>
-      <p:sp>
-        <p:nvSpPr>
-          <p:cNvPr id="90" name="Text 88"/>
-          <p:cNvSpPr txBox="1"/>
-          <p:nvPr/>
-        </p:nvSpPr>
-        <p:spPr>
-          <a:xfrm rot="5400000">
-            <a:off x="10853928" y="4005072"/>
-            <a:ext cx="2103120" cy="219456"/>
+          <p:cNvPr id="84" name="Text 82"/>
+          <p:cNvSpPr txBox="1"/>
+          <p:nvPr/>
+        </p:nvSpPr>
+        <p:spPr>
+          <a:xfrm>
+            <a:off x="10515600" y="5385816"/>
+            <a:ext cx="914400" cy="530352"/>
           </a:xfrm>
           <a:prstGeom prst="rect">
             <a:avLst/>
@@ -3929,12 +3871,98 @@
               <a:buNone/>
             </a:pPr>
             <a:r>
-              <a:rPr lang="en-US" sz="900" b="1" dirty="0">
-                <a:solidFill>
-                  <a:schemeClr val="accent1"/>
-                </a:solidFill>
-              </a:rPr>
-              <a:t>단계별 사업 확대 · 타 그룹사 확산</a:t>
+              <a:rPr lang="en-US" sz="950" b="1" dirty="0">
+                <a:solidFill>
+                  <a:schemeClr val="bg1"/>
+                </a:solidFill>
+              </a:rPr>
+              <a:t>사업부 본사업</a:t>
+            </a:r>
+            <a:endParaRPr lang="en-US" sz="950" dirty="0"/>
+          </a:p>
+          <a:p>
+            <a:pPr algn="ctr" indent="0" marL="0">
+              <a:buNone/>
+            </a:pPr>
+            <a:r>
+              <a:rPr lang="en-US" sz="850" dirty="0">
+                <a:solidFill>
+                  <a:schemeClr val="bg1"/>
+                </a:solidFill>
+              </a:rPr>
+              <a:t>'27</a:t>
+            </a:r>
+            <a:endParaRPr lang="en-US" sz="950" dirty="0"/>
+          </a:p>
+        </p:txBody>
+      </p:sp>
+      <p:sp>
+        <p:nvSpPr>
+          <p:cNvPr id="85" name="Text 83"/>
+          <p:cNvSpPr txBox="1"/>
+          <p:nvPr/>
+        </p:nvSpPr>
+        <p:spPr>
+          <a:xfrm>
+            <a:off x="10424160" y="5952744"/>
+            <a:ext cx="1097280" cy="329184"/>
+          </a:xfrm>
+          <a:prstGeom prst="rect">
+            <a:avLst/>
+          </a:prstGeom>
+          <a:noFill/>
+          <a:ln/>
+        </p:spPr>
+        <p:txBody>
+          <a:bodyPr wrap="square" lIns="0" tIns="0" rIns="0" bIns="0" rtlCol="0" anchor="t"/>
+          <a:lstStyle/>
+          <a:p>
+            <a:pPr algn="ctr" indent="0" marL="0">
+              <a:buNone/>
+            </a:pPr>
+            <a:r>
+              <a:rPr lang="en-US" sz="900" dirty="0">
+                <a:solidFill>
+                  <a:schemeClr val="tx2"/>
+                </a:solidFill>
+              </a:rPr>
+              <a:t>통합 e커머스 구축</a:t>
+            </a:r>
+            <a:endParaRPr lang="en-US" sz="900" dirty="0"/>
+          </a:p>
+        </p:txBody>
+      </p:sp>
+      <p:sp>
+        <p:nvSpPr>
+          <p:cNvPr id="86" name="Text 84"/>
+          <p:cNvSpPr txBox="1"/>
+          <p:nvPr/>
+        </p:nvSpPr>
+        <p:spPr>
+          <a:xfrm>
+            <a:off x="5577840" y="6291072"/>
+            <a:ext cx="6016752" cy="201168"/>
+          </a:xfrm>
+          <a:prstGeom prst="rect">
+            <a:avLst/>
+          </a:prstGeom>
+          <a:noFill/>
+          <a:ln/>
+        </p:spPr>
+        <p:txBody>
+          <a:bodyPr wrap="square" lIns="0" tIns="0" rIns="0" bIns="0" rtlCol="0" anchor="ctr"/>
+          <a:lstStyle/>
+          <a:p>
+            <a:pPr algn="ctr" indent="0" marL="0">
+              <a:buNone/>
+            </a:pPr>
+            <a:r>
+              <a:rPr lang="en-US" sz="900" dirty="0">
+                <a:solidFill>
+                  <a:schemeClr val="accent5"/>
+                </a:solidFill>
+              </a:rPr>
+              <a:t>※ 투입: Advisor 1, 퍼실리테이터 N, AI 전문가 N  /  산출물: Agent 기획서, 프로토타입 3종</a:t>
             </a:r>
             <a:endParaRPr lang="en-US" sz="900" dirty="0"/>
           </a:p>

</xml_diff>

<commit_message>
Rework left boxes: revised background, purpose, and 3-stage plan
Co-Authored-By: Claude Opus 5.5 <noreply@anthropic.com>
Claude-Session: https://claude.ai/code/session_01WNEGybX95CXr34MGwdFDgp
</commit_message>
<xml_diff>
--- a/AX_Education_Task1.pptx
+++ b/AX_Education_Task1.pptx
@@ -107,7 +107,7 @@
   <p:extLst>
     <p:ext uri="{521415D9-36F7-43E2-AB2F-B90AF26B5E84}">
       <p14:sectionLst xmlns:p14="http://schemas.microsoft.com/office/powerpoint/2010/main">
-        <p14:section name="과제1 AX교육" id="{1620c140-9431-36f3-bdad-fff7d9b6db3b}">
+        <p14:section name="과제1 AX교육" id="{c3c8bb4e-9f1e-60fe-e793-117204c47e54}">
           <p14:sldIdLst>
             <p14:sldId id="256"/>
           </p14:sldIdLst>
@@ -1432,7 +1432,7 @@
         <p:spPr>
           <a:xfrm>
             <a:off x="1417320" y="1600200"/>
-            <a:ext cx="2834640" cy="1463040"/>
+            <a:ext cx="2834640" cy="1600200"/>
           </a:xfrm>
           <a:prstGeom prst="rect">
             <a:avLst/>
@@ -1457,7 +1457,7 @@
         <p:spPr>
           <a:xfrm>
             <a:off x="1417320" y="1600200"/>
-            <a:ext cx="2834640" cy="310896"/>
+            <a:ext cx="2834640" cy="246888"/>
           </a:xfrm>
           <a:prstGeom prst="rect">
             <a:avLst/>
@@ -1482,100 +1482,493 @@
         <p:spPr>
           <a:xfrm>
             <a:off x="1417320" y="1600200"/>
-            <a:ext cx="2834640" cy="310896"/>
-          </a:xfrm>
-          <a:prstGeom prst="rect">
-            <a:avLst/>
-          </a:prstGeom>
-          <a:noFill/>
-          <a:ln/>
-        </p:spPr>
-        <p:txBody>
-          <a:bodyPr wrap="square" lIns="0" tIns="0" rIns="0" bIns="0" rtlCol="0" anchor="ctr"/>
-          <a:lstStyle/>
-          <a:p>
-            <a:pPr algn="ctr" indent="0" marL="0">
-              <a:buNone/>
-            </a:pPr>
-            <a:r>
-              <a:rPr lang="en-US" sz="1300" b="1" dirty="0">
+            <a:ext cx="2834640" cy="246888"/>
+          </a:xfrm>
+          <a:prstGeom prst="rect">
+            <a:avLst/>
+          </a:prstGeom>
+          <a:noFill/>
+          <a:ln/>
+        </p:spPr>
+        <p:txBody>
+          <a:bodyPr wrap="square" lIns="0" tIns="0" rIns="0" bIns="0" rtlCol="0" anchor="ctr"/>
+          <a:lstStyle/>
+          <a:p>
+            <a:pPr algn="ctr" indent="0" marL="0">
+              <a:buNone/>
+            </a:pPr>
+            <a:r>
+              <a:rPr lang="en-US" sz="1200" b="1" dirty="0">
                 <a:solidFill>
                   <a:schemeClr val="tx1"/>
                 </a:solidFill>
               </a:rPr>
               <a:t>추진 배경</a:t>
             </a:r>
-            <a:endParaRPr lang="en-US" sz="1300" dirty="0"/>
-          </a:p>
-        </p:txBody>
-      </p:sp>
-      <p:sp>
-        <p:nvSpPr>
-          <p:cNvPr id="18" name="Text 16"/>
-          <p:cNvSpPr txBox="1"/>
-          <p:nvPr/>
-        </p:nvSpPr>
-        <p:spPr>
-          <a:xfrm>
-            <a:off x="1508760" y="1984248"/>
-            <a:ext cx="2670048" cy="1005840"/>
-          </a:xfrm>
-          <a:prstGeom prst="rect">
-            <a:avLst/>
-          </a:prstGeom>
-          <a:noFill/>
-          <a:ln/>
-        </p:spPr>
-        <p:txBody>
-          <a:bodyPr wrap="square" lIns="0" tIns="0" rIns="0" bIns="0" rtlCol="0" anchor="t"/>
-          <a:lstStyle/>
-          <a:p>
-            <a:pPr marL="127000" indent="-127000">
-              <a:spcAft>
-                <a:spcPts val="400"/>
-              </a:spcAft>
-              <a:buSzPct val="100000"/>
-              <a:buChar char="•"/>
-            </a:pPr>
-            <a:r>
-              <a:rPr lang="en-US" sz="1050" dirty="0">
+            <a:endParaRPr lang="en-US" sz="1200" dirty="0"/>
+          </a:p>
+        </p:txBody>
+      </p:sp>
+      <p:sp>
+        <p:nvSpPr>
+          <p:cNvPr id="18" name="Shape 16"/>
+          <p:cNvSpPr/>
+          <p:nvPr/>
+        </p:nvSpPr>
+        <p:spPr>
+          <a:xfrm>
+            <a:off x="1490472" y="1883664"/>
+            <a:ext cx="2688336" cy="292608"/>
+          </a:xfrm>
+          <a:prstGeom prst="rect">
+            <a:avLst/>
+          </a:prstGeom>
+          <a:solidFill>
+            <a:schemeClr val="tx2"/>
+          </a:solidFill>
+          <a:ln/>
+        </p:spPr>
+      </p:sp>
+      <p:sp>
+        <p:nvSpPr>
+          <p:cNvPr id="19" name="Text 17"/>
+          <p:cNvSpPr txBox="1"/>
+          <p:nvPr/>
+        </p:nvSpPr>
+        <p:spPr>
+          <a:xfrm>
+            <a:off x="1490472" y="1883664"/>
+            <a:ext cx="2688336" cy="292608"/>
+          </a:xfrm>
+          <a:prstGeom prst="rect">
+            <a:avLst/>
+          </a:prstGeom>
+          <a:noFill/>
+          <a:ln/>
+        </p:spPr>
+        <p:txBody>
+          <a:bodyPr wrap="square" lIns="0" tIns="0" rIns="0" bIns="0" rtlCol="0" anchor="ctr"/>
+          <a:lstStyle/>
+          <a:p>
+            <a:pPr algn="ctr" indent="0" marL="0">
+              <a:buNone/>
+            </a:pPr>
+            <a:r>
+              <a:rPr lang="en-US" sz="950" b="1" dirty="0">
+                <a:solidFill>
+                  <a:schemeClr val="bg1"/>
+                </a:solidFill>
+              </a:rPr>
+              <a:t>개인 AI 활용은 확산, 조직 혁신 해법은 부재</a:t>
+            </a:r>
+            <a:endParaRPr lang="en-US" sz="950" dirty="0"/>
+          </a:p>
+        </p:txBody>
+      </p:sp>
+      <p:sp>
+        <p:nvSpPr>
+          <p:cNvPr id="20" name="Shape 18"/>
+          <p:cNvSpPr/>
+          <p:nvPr/>
+        </p:nvSpPr>
+        <p:spPr>
+          <a:xfrm>
+            <a:off x="1490472" y="2212848"/>
+            <a:ext cx="865632" cy="365760"/>
+          </a:xfrm>
+          <a:prstGeom prst="rect">
+            <a:avLst/>
+          </a:prstGeom>
+          <a:solidFill>
+            <a:schemeClr val="bg2"/>
+          </a:solidFill>
+          <a:ln w="6350">
+            <a:solidFill>
+              <a:schemeClr val="accent4"/>
+            </a:solidFill>
+            <a:prstDash val="solid"/>
+          </a:ln>
+        </p:spPr>
+      </p:sp>
+      <p:sp>
+        <p:nvSpPr>
+          <p:cNvPr id="21" name="Text 19"/>
+          <p:cNvSpPr txBox="1"/>
+          <p:nvPr/>
+        </p:nvSpPr>
+        <p:spPr>
+          <a:xfrm>
+            <a:off x="1517904" y="2212848"/>
+            <a:ext cx="810768" cy="365760"/>
+          </a:xfrm>
+          <a:prstGeom prst="rect">
+            <a:avLst/>
+          </a:prstGeom>
+          <a:noFill/>
+          <a:ln/>
+        </p:spPr>
+        <p:txBody>
+          <a:bodyPr wrap="square" lIns="0" tIns="0" rIns="0" bIns="0" rtlCol="0" anchor="ctr"/>
+          <a:lstStyle/>
+          <a:p>
+            <a:pPr algn="ctr" indent="0" marL="0">
+              <a:buNone/>
+            </a:pPr>
+            <a:r>
+              <a:rPr lang="en-US" sz="850" dirty="0">
                 <a:solidFill>
                   <a:schemeClr val="tx2"/>
                 </a:solidFill>
               </a:rPr>
-              <a:t>그룹사 AX 공감대는 높으나 현업의 AI 활용 경험·실행 과제 부족</a:t>
-            </a:r>
-            <a:endParaRPr lang="en-US" sz="1050" dirty="0"/>
-          </a:p>
-          <a:p>
-            <a:pPr marL="127000" indent="-127000">
-              <a:spcAft>
-                <a:spcPts val="400"/>
-              </a:spcAft>
-              <a:buSzPct val="100000"/>
-              <a:buChar char="•"/>
-            </a:pPr>
-            <a:r>
-              <a:rPr lang="en-US" sz="1050" dirty="0">
+              <a:t>개인 단위</a:t>
+            </a:r>
+            <a:endParaRPr lang="en-US" sz="850" dirty="0"/>
+          </a:p>
+          <a:p>
+            <a:pPr algn="ctr" indent="0" marL="0">
+              <a:buNone/>
+            </a:pPr>
+            <a:r>
+              <a:rPr lang="en-US" sz="850" dirty="0">
                 <a:solidFill>
                   <a:schemeClr val="tx2"/>
                 </a:solidFill>
               </a:rPr>
-              <a:t>Top-down 과제 발굴의 현장 적합성 한계 → 현업 주도 변화관리 필요</a:t>
-            </a:r>
-            <a:endParaRPr lang="en-US" sz="1050" dirty="0"/>
-          </a:p>
-        </p:txBody>
-      </p:sp>
-      <p:sp>
-        <p:nvSpPr>
-          <p:cNvPr id="19" name="left-box-2"/>
-          <p:cNvSpPr/>
-          <p:nvPr/>
-        </p:nvSpPr>
-        <p:spPr>
-          <a:xfrm>
-            <a:off x="1417320" y="3154680"/>
+              <a:t>AI 활용 확산</a:t>
+            </a:r>
+            <a:endParaRPr lang="en-US" sz="850" dirty="0"/>
+          </a:p>
+        </p:txBody>
+      </p:sp>
+      <p:sp>
+        <p:nvSpPr>
+          <p:cNvPr id="22" name="Shape 20"/>
+          <p:cNvSpPr/>
+          <p:nvPr/>
+        </p:nvSpPr>
+        <p:spPr>
+          <a:xfrm>
+            <a:off x="2401824" y="2212848"/>
+            <a:ext cx="865632" cy="365760"/>
+          </a:xfrm>
+          <a:prstGeom prst="rect">
+            <a:avLst/>
+          </a:prstGeom>
+          <a:solidFill>
+            <a:schemeClr val="bg2"/>
+          </a:solidFill>
+          <a:ln w="6350">
+            <a:solidFill>
+              <a:schemeClr val="accent4"/>
+            </a:solidFill>
+            <a:prstDash val="solid"/>
+          </a:ln>
+        </p:spPr>
+      </p:sp>
+      <p:sp>
+        <p:nvSpPr>
+          <p:cNvPr id="23" name="Text 21"/>
+          <p:cNvSpPr txBox="1"/>
+          <p:nvPr/>
+        </p:nvSpPr>
+        <p:spPr>
+          <a:xfrm>
+            <a:off x="2429256" y="2212848"/>
+            <a:ext cx="810768" cy="365760"/>
+          </a:xfrm>
+          <a:prstGeom prst="rect">
+            <a:avLst/>
+          </a:prstGeom>
+          <a:noFill/>
+          <a:ln/>
+        </p:spPr>
+        <p:txBody>
+          <a:bodyPr wrap="square" lIns="0" tIns="0" rIns="0" bIns="0" rtlCol="0" anchor="ctr"/>
+          <a:lstStyle/>
+          <a:p>
+            <a:pPr algn="ctr" indent="0" marL="0">
+              <a:buNone/>
+            </a:pPr>
+            <a:r>
+              <a:rPr lang="en-US" sz="850" dirty="0">
+                <a:solidFill>
+                  <a:schemeClr val="tx2"/>
+                </a:solidFill>
+              </a:rPr>
+              <a:t>실무자</a:t>
+            </a:r>
+            <a:endParaRPr lang="en-US" sz="850" dirty="0"/>
+          </a:p>
+          <a:p>
+            <a:pPr algn="ctr" indent="0" marL="0">
+              <a:buNone/>
+            </a:pPr>
+            <a:r>
+              <a:rPr lang="en-US" sz="850" dirty="0">
+                <a:solidFill>
+                  <a:schemeClr val="tx2"/>
+                </a:solidFill>
+              </a:rPr>
+              <a:t>AI 활용 니즈↑</a:t>
+            </a:r>
+            <a:endParaRPr lang="en-US" sz="850" dirty="0"/>
+          </a:p>
+        </p:txBody>
+      </p:sp>
+      <p:sp>
+        <p:nvSpPr>
+          <p:cNvPr id="24" name="Shape 22"/>
+          <p:cNvSpPr/>
+          <p:nvPr/>
+        </p:nvSpPr>
+        <p:spPr>
+          <a:xfrm>
+            <a:off x="3313176" y="2212848"/>
+            <a:ext cx="865632" cy="365760"/>
+          </a:xfrm>
+          <a:prstGeom prst="rect">
+            <a:avLst/>
+          </a:prstGeom>
+          <a:solidFill>
+            <a:schemeClr val="bg2"/>
+          </a:solidFill>
+          <a:ln w="6350">
+            <a:solidFill>
+              <a:schemeClr val="accent4"/>
+            </a:solidFill>
+            <a:prstDash val="solid"/>
+          </a:ln>
+        </p:spPr>
+      </p:sp>
+      <p:sp>
+        <p:nvSpPr>
+          <p:cNvPr id="25" name="Text 23"/>
+          <p:cNvSpPr txBox="1"/>
+          <p:nvPr/>
+        </p:nvSpPr>
+        <p:spPr>
+          <a:xfrm>
+            <a:off x="3340608" y="2212848"/>
+            <a:ext cx="810768" cy="365760"/>
+          </a:xfrm>
+          <a:prstGeom prst="rect">
+            <a:avLst/>
+          </a:prstGeom>
+          <a:noFill/>
+          <a:ln/>
+        </p:spPr>
+        <p:txBody>
+          <a:bodyPr wrap="square" lIns="0" tIns="0" rIns="0" bIns="0" rtlCol="0" anchor="ctr"/>
+          <a:lstStyle/>
+          <a:p>
+            <a:pPr algn="ctr" indent="0" marL="0">
+              <a:buNone/>
+            </a:pPr>
+            <a:r>
+              <a:rPr lang="en-US" sz="850" dirty="0">
+                <a:solidFill>
+                  <a:schemeClr val="tx2"/>
+                </a:solidFill>
+              </a:rPr>
+              <a:t>조직 단위</a:t>
+            </a:r>
+            <a:endParaRPr lang="en-US" sz="850" dirty="0"/>
+          </a:p>
+          <a:p>
+            <a:pPr algn="ctr" indent="0" marL="0">
+              <a:buNone/>
+            </a:pPr>
+            <a:r>
+              <a:rPr lang="en-US" sz="850" dirty="0">
+                <a:solidFill>
+                  <a:schemeClr val="tx2"/>
+                </a:solidFill>
+              </a:rPr>
+              <a:t>혁신 해법 부재</a:t>
+            </a:r>
+            <a:endParaRPr lang="en-US" sz="850" dirty="0"/>
+          </a:p>
+        </p:txBody>
+      </p:sp>
+      <p:sp>
+        <p:nvSpPr>
+          <p:cNvPr id="26" name="Shape 24"/>
+          <p:cNvSpPr/>
+          <p:nvPr/>
+        </p:nvSpPr>
+        <p:spPr>
+          <a:xfrm rot="10800000">
+            <a:off x="2724912" y="2606040"/>
+            <a:ext cx="219456" cy="109728"/>
+          </a:xfrm>
+          <a:prstGeom prst="triangle">
+            <a:avLst/>
+          </a:prstGeom>
+          <a:solidFill>
+            <a:schemeClr val="tx1"/>
+          </a:solidFill>
+          <a:ln/>
+        </p:spPr>
+      </p:sp>
+      <p:sp>
+        <p:nvSpPr>
+          <p:cNvPr id="27" name="Shape 25"/>
+          <p:cNvSpPr/>
+          <p:nvPr/>
+        </p:nvSpPr>
+        <p:spPr>
+          <a:xfrm>
+            <a:off x="1490472" y="2743200"/>
+            <a:ext cx="1316736" cy="329184"/>
+          </a:xfrm>
+          <a:prstGeom prst="rect">
+            <a:avLst/>
+          </a:prstGeom>
+          <a:solidFill>
+            <a:schemeClr val="bg1"/>
+          </a:solidFill>
+          <a:ln w="15875">
+            <a:solidFill>
+              <a:schemeClr val="accent3"/>
+            </a:solidFill>
+            <a:prstDash val="solid"/>
+          </a:ln>
+        </p:spPr>
+      </p:sp>
+      <p:sp>
+        <p:nvSpPr>
+          <p:cNvPr id="28" name="Text 26"/>
+          <p:cNvSpPr txBox="1"/>
+          <p:nvPr/>
+        </p:nvSpPr>
+        <p:spPr>
+          <a:xfrm>
+            <a:off x="1517904" y="2743200"/>
+            <a:ext cx="1261872" cy="329184"/>
+          </a:xfrm>
+          <a:prstGeom prst="rect">
+            <a:avLst/>
+          </a:prstGeom>
+          <a:noFill/>
+          <a:ln/>
+        </p:spPr>
+        <p:txBody>
+          <a:bodyPr wrap="square" lIns="0" tIns="0" rIns="0" bIns="0" rtlCol="0" anchor="ctr"/>
+          <a:lstStyle/>
+          <a:p>
+            <a:pPr algn="ctr" indent="0" marL="0">
+              <a:buNone/>
+            </a:pPr>
+            <a:r>
+              <a:rPr lang="en-US" sz="850" b="1" dirty="0">
+                <a:solidFill>
+                  <a:schemeClr val="accent3"/>
+                </a:solidFill>
+              </a:rPr>
+              <a:t>실무자 중심</a:t>
+            </a:r>
+            <a:endParaRPr lang="en-US" sz="850" dirty="0"/>
+          </a:p>
+          <a:p>
+            <a:pPr algn="ctr" indent="0" marL="0">
+              <a:buNone/>
+            </a:pPr>
+            <a:r>
+              <a:rPr lang="en-US" sz="850" b="1" dirty="0">
+                <a:solidFill>
+                  <a:schemeClr val="accent3"/>
+                </a:solidFill>
+              </a:rPr>
+              <a:t>조직 업무 혁신 해법 필요</a:t>
+            </a:r>
+            <a:endParaRPr lang="en-US" sz="850" dirty="0"/>
+          </a:p>
+        </p:txBody>
+      </p:sp>
+      <p:sp>
+        <p:nvSpPr>
+          <p:cNvPr id="29" name="Shape 27"/>
+          <p:cNvSpPr/>
+          <p:nvPr/>
+        </p:nvSpPr>
+        <p:spPr>
+          <a:xfrm>
+            <a:off x="2862072" y="2743200"/>
+            <a:ext cx="1316736" cy="329184"/>
+          </a:xfrm>
+          <a:prstGeom prst="rect">
+            <a:avLst/>
+          </a:prstGeom>
+          <a:solidFill>
+            <a:schemeClr val="bg1"/>
+          </a:solidFill>
+          <a:ln w="15875">
+            <a:solidFill>
+              <a:schemeClr val="accent3"/>
+            </a:solidFill>
+            <a:prstDash val="solid"/>
+          </a:ln>
+        </p:spPr>
+      </p:sp>
+      <p:sp>
+        <p:nvSpPr>
+          <p:cNvPr id="30" name="Text 28"/>
+          <p:cNvSpPr txBox="1"/>
+          <p:nvPr/>
+        </p:nvSpPr>
+        <p:spPr>
+          <a:xfrm>
+            <a:off x="2889504" y="2743200"/>
+            <a:ext cx="1261872" cy="329184"/>
+          </a:xfrm>
+          <a:prstGeom prst="rect">
+            <a:avLst/>
+          </a:prstGeom>
+          <a:noFill/>
+          <a:ln/>
+        </p:spPr>
+        <p:txBody>
+          <a:bodyPr wrap="square" lIns="0" tIns="0" rIns="0" bIns="0" rtlCol="0" anchor="ctr"/>
+          <a:lstStyle/>
+          <a:p>
+            <a:pPr algn="ctr" indent="0" marL="0">
+              <a:buNone/>
+            </a:pPr>
+            <a:r>
+              <a:rPr lang="en-US" sz="850" b="1" dirty="0">
+                <a:solidFill>
+                  <a:schemeClr val="accent3"/>
+                </a:solidFill>
+              </a:rPr>
+              <a:t>개인 활용 넘어</a:t>
+            </a:r>
+            <a:endParaRPr lang="en-US" sz="850" dirty="0"/>
+          </a:p>
+          <a:p>
+            <a:pPr algn="ctr" indent="0" marL="0">
+              <a:buNone/>
+            </a:pPr>
+            <a:r>
+              <a:rPr lang="en-US" sz="850" b="1" dirty="0">
+                <a:solidFill>
+                  <a:schemeClr val="accent3"/>
+                </a:solidFill>
+              </a:rPr>
+              <a:t>프로세스 단위 AX 필요</a:t>
+            </a:r>
+            <a:endParaRPr lang="en-US" sz="850" dirty="0"/>
+          </a:p>
+        </p:txBody>
+      </p:sp>
+      <p:sp>
+        <p:nvSpPr>
+          <p:cNvPr id="31" name="left-box-2"/>
+          <p:cNvSpPr/>
+          <p:nvPr/>
+        </p:nvSpPr>
+        <p:spPr>
+          <a:xfrm>
+            <a:off x="1417320" y="3273552"/>
             <a:ext cx="2834640" cy="1600200"/>
           </a:xfrm>
           <a:prstGeom prst="rect">
@@ -1594,14 +1987,14 @@
       </p:sp>
       <p:sp>
         <p:nvSpPr>
-          <p:cNvPr id="20" name="Shape 18"/>
-          <p:cNvSpPr/>
-          <p:nvPr/>
-        </p:nvSpPr>
-        <p:spPr>
-          <a:xfrm>
-            <a:off x="1417320" y="3154680"/>
-            <a:ext cx="2834640" cy="310896"/>
+          <p:cNvPr id="32" name="Shape 30"/>
+          <p:cNvSpPr/>
+          <p:nvPr/>
+        </p:nvSpPr>
+        <p:spPr>
+          <a:xfrm>
+            <a:off x="1417320" y="3273552"/>
+            <a:ext cx="2834640" cy="246888"/>
           </a:xfrm>
           <a:prstGeom prst="rect">
             <a:avLst/>
@@ -1619,108 +2012,426 @@
       </p:sp>
       <p:sp>
         <p:nvSpPr>
-          <p:cNvPr id="21" name="Text 19"/>
-          <p:cNvSpPr txBox="1"/>
-          <p:nvPr/>
-        </p:nvSpPr>
-        <p:spPr>
-          <a:xfrm>
-            <a:off x="1417320" y="3154680"/>
-            <a:ext cx="2834640" cy="310896"/>
-          </a:xfrm>
-          <a:prstGeom prst="rect">
-            <a:avLst/>
-          </a:prstGeom>
-          <a:noFill/>
-          <a:ln/>
-        </p:spPr>
-        <p:txBody>
-          <a:bodyPr wrap="square" lIns="0" tIns="0" rIns="0" bIns="0" rtlCol="0" anchor="ctr"/>
-          <a:lstStyle/>
-          <a:p>
-            <a:pPr algn="ctr" indent="0" marL="0">
-              <a:buNone/>
-            </a:pPr>
-            <a:r>
-              <a:rPr lang="en-US" sz="1300" b="1" dirty="0">
+          <p:cNvPr id="33" name="Text 31"/>
+          <p:cNvSpPr txBox="1"/>
+          <p:nvPr/>
+        </p:nvSpPr>
+        <p:spPr>
+          <a:xfrm>
+            <a:off x="1417320" y="3273552"/>
+            <a:ext cx="2834640" cy="246888"/>
+          </a:xfrm>
+          <a:prstGeom prst="rect">
+            <a:avLst/>
+          </a:prstGeom>
+          <a:noFill/>
+          <a:ln/>
+        </p:spPr>
+        <p:txBody>
+          <a:bodyPr wrap="square" lIns="0" tIns="0" rIns="0" bIns="0" rtlCol="0" anchor="ctr"/>
+          <a:lstStyle/>
+          <a:p>
+            <a:pPr algn="ctr" indent="0" marL="0">
+              <a:buNone/>
+            </a:pPr>
+            <a:r>
+              <a:rPr lang="en-US" sz="1200" b="1" dirty="0">
                 <a:solidFill>
                   <a:schemeClr val="tx1"/>
                 </a:solidFill>
               </a:rPr>
               <a:t>추진 목적</a:t>
             </a:r>
-            <a:endParaRPr lang="en-US" sz="1300" dirty="0"/>
-          </a:p>
-        </p:txBody>
-      </p:sp>
-      <p:sp>
-        <p:nvSpPr>
-          <p:cNvPr id="22" name="Text 20"/>
-          <p:cNvSpPr txBox="1"/>
-          <p:nvPr/>
-        </p:nvSpPr>
-        <p:spPr>
-          <a:xfrm>
-            <a:off x="1508760" y="3538728"/>
-            <a:ext cx="2670048" cy="1143000"/>
-          </a:xfrm>
-          <a:prstGeom prst="rect">
-            <a:avLst/>
-          </a:prstGeom>
-          <a:noFill/>
-          <a:ln/>
-        </p:spPr>
-        <p:txBody>
-          <a:bodyPr wrap="square" lIns="0" tIns="0" rIns="0" bIns="0" rtlCol="0" anchor="t"/>
-          <a:lstStyle/>
-          <a:p>
-            <a:pPr marL="127000" indent="-127000">
-              <a:spcAft>
-                <a:spcPts val="400"/>
-              </a:spcAft>
-              <a:buSzPct val="100000"/>
-              <a:buChar char="•"/>
-            </a:pPr>
-            <a:r>
-              <a:rPr lang="en-US" sz="1050" dirty="0">
+            <a:endParaRPr lang="en-US" sz="1200" dirty="0"/>
+          </a:p>
+        </p:txBody>
+      </p:sp>
+      <p:sp>
+        <p:nvSpPr>
+          <p:cNvPr id="34" name="Shape 32"/>
+          <p:cNvSpPr/>
+          <p:nvPr/>
+        </p:nvSpPr>
+        <p:spPr>
+          <a:xfrm>
+            <a:off x="1490472" y="3557016"/>
+            <a:ext cx="2688336" cy="292608"/>
+          </a:xfrm>
+          <a:prstGeom prst="rect">
+            <a:avLst/>
+          </a:prstGeom>
+          <a:solidFill>
+            <a:schemeClr val="tx2"/>
+          </a:solidFill>
+          <a:ln/>
+        </p:spPr>
+      </p:sp>
+      <p:sp>
+        <p:nvSpPr>
+          <p:cNvPr id="35" name="Text 33"/>
+          <p:cNvSpPr txBox="1"/>
+          <p:nvPr/>
+        </p:nvSpPr>
+        <p:spPr>
+          <a:xfrm>
+            <a:off x="1490472" y="3557016"/>
+            <a:ext cx="2688336" cy="292608"/>
+          </a:xfrm>
+          <a:prstGeom prst="rect">
+            <a:avLst/>
+          </a:prstGeom>
+          <a:noFill/>
+          <a:ln/>
+        </p:spPr>
+        <p:txBody>
+          <a:bodyPr wrap="square" lIns="0" tIns="0" rIns="0" bIns="0" rtlCol="0" anchor="ctr"/>
+          <a:lstStyle/>
+          <a:p>
+            <a:pPr algn="ctr" indent="0" marL="0">
+              <a:buNone/>
+            </a:pPr>
+            <a:r>
+              <a:rPr lang="en-US" sz="950" b="1" dirty="0">
+                <a:solidFill>
+                  <a:schemeClr val="bg1"/>
+                </a:solidFill>
+              </a:rPr>
+              <a:t>현업 주도형 AX 과제 발굴·구현 프로그램</a:t>
+            </a:r>
+            <a:endParaRPr lang="en-US" sz="950" dirty="0"/>
+          </a:p>
+        </p:txBody>
+      </p:sp>
+      <p:sp>
+        <p:nvSpPr>
+          <p:cNvPr id="36" name="Shape 34"/>
+          <p:cNvSpPr/>
+          <p:nvPr/>
+        </p:nvSpPr>
+        <p:spPr>
+          <a:xfrm>
+            <a:off x="1490472" y="3886200"/>
+            <a:ext cx="1321308" cy="365760"/>
+          </a:xfrm>
+          <a:prstGeom prst="rect">
+            <a:avLst/>
+          </a:prstGeom>
+          <a:solidFill>
+            <a:schemeClr val="bg2"/>
+          </a:solidFill>
+          <a:ln w="6350">
+            <a:solidFill>
+              <a:schemeClr val="accent4"/>
+            </a:solidFill>
+            <a:prstDash val="solid"/>
+          </a:ln>
+        </p:spPr>
+      </p:sp>
+      <p:sp>
+        <p:nvSpPr>
+          <p:cNvPr id="37" name="Text 35"/>
+          <p:cNvSpPr txBox="1"/>
+          <p:nvPr/>
+        </p:nvSpPr>
+        <p:spPr>
+          <a:xfrm>
+            <a:off x="1517904" y="3886200"/>
+            <a:ext cx="1266444" cy="365760"/>
+          </a:xfrm>
+          <a:prstGeom prst="rect">
+            <a:avLst/>
+          </a:prstGeom>
+          <a:noFill/>
+          <a:ln/>
+        </p:spPr>
+        <p:txBody>
+          <a:bodyPr wrap="square" lIns="0" tIns="0" rIns="0" bIns="0" rtlCol="0" anchor="ctr"/>
+          <a:lstStyle/>
+          <a:p>
+            <a:pPr algn="ctr" indent="0" marL="0">
+              <a:buNone/>
+            </a:pPr>
+            <a:r>
+              <a:rPr lang="en-US" sz="850" dirty="0">
                 <a:solidFill>
                   <a:schemeClr val="tx2"/>
                 </a:solidFill>
               </a:rPr>
-              <a:t>현업이 자기 업무 데이터로 Pain Point를 찾고 AI Agent 과제를 설계·구현</a:t>
-            </a:r>
-            <a:endParaRPr lang="en-US" sz="1050" dirty="0"/>
-          </a:p>
-          <a:p>
-            <a:pPr marL="127000" indent="-127000">
-              <a:spcAft>
-                <a:spcPts val="400"/>
-              </a:spcAft>
-              <a:buSzPct val="100000"/>
-              <a:buChar char="•"/>
-            </a:pPr>
-            <a:r>
-              <a:rPr lang="en-US" sz="1050" dirty="0">
+              <a:t>개인 AI 활용 →</a:t>
+            </a:r>
+            <a:endParaRPr lang="en-US" sz="850" dirty="0"/>
+          </a:p>
+          <a:p>
+            <a:pPr algn="ctr" indent="0" marL="0">
+              <a:buNone/>
+            </a:pPr>
+            <a:r>
+              <a:rPr lang="en-US" sz="850" dirty="0">
                 <a:solidFill>
                   <a:schemeClr val="tx2"/>
                 </a:solidFill>
               </a:rPr>
-              <a:t>교육 산출물(Agent 기획서·프로토타입)을 AX진단으로 연계 → 사업 Open Door</a:t>
-            </a:r>
-            <a:endParaRPr lang="en-US" sz="1050" dirty="0"/>
-          </a:p>
-        </p:txBody>
-      </p:sp>
-      <p:sp>
-        <p:nvSpPr>
-          <p:cNvPr id="23" name="left-box-3"/>
-          <p:cNvSpPr/>
-          <p:nvPr/>
-        </p:nvSpPr>
-        <p:spPr>
-          <a:xfrm>
-            <a:off x="1417320" y="4846320"/>
-            <a:ext cx="2834640" cy="1691640"/>
+              <a:t>조직 혁신 과제로 확장</a:t>
+            </a:r>
+            <a:endParaRPr lang="en-US" sz="850" dirty="0"/>
+          </a:p>
+        </p:txBody>
+      </p:sp>
+      <p:sp>
+        <p:nvSpPr>
+          <p:cNvPr id="38" name="Shape 36"/>
+          <p:cNvSpPr/>
+          <p:nvPr/>
+        </p:nvSpPr>
+        <p:spPr>
+          <a:xfrm>
+            <a:off x="2857500" y="3886200"/>
+            <a:ext cx="1321308" cy="365760"/>
+          </a:xfrm>
+          <a:prstGeom prst="rect">
+            <a:avLst/>
+          </a:prstGeom>
+          <a:solidFill>
+            <a:schemeClr val="bg2"/>
+          </a:solidFill>
+          <a:ln w="6350">
+            <a:solidFill>
+              <a:schemeClr val="accent4"/>
+            </a:solidFill>
+            <a:prstDash val="solid"/>
+          </a:ln>
+        </p:spPr>
+      </p:sp>
+      <p:sp>
+        <p:nvSpPr>
+          <p:cNvPr id="39" name="Text 37"/>
+          <p:cNvSpPr txBox="1"/>
+          <p:nvPr/>
+        </p:nvSpPr>
+        <p:spPr>
+          <a:xfrm>
+            <a:off x="2884932" y="3886200"/>
+            <a:ext cx="1266444" cy="365760"/>
+          </a:xfrm>
+          <a:prstGeom prst="rect">
+            <a:avLst/>
+          </a:prstGeom>
+          <a:noFill/>
+          <a:ln/>
+        </p:spPr>
+        <p:txBody>
+          <a:bodyPr wrap="square" lIns="0" tIns="0" rIns="0" bIns="0" rtlCol="0" anchor="ctr"/>
+          <a:lstStyle/>
+          <a:p>
+            <a:pPr algn="ctr" indent="0" marL="0">
+              <a:buNone/>
+            </a:pPr>
+            <a:r>
+              <a:rPr lang="en-US" sz="850" dirty="0">
+                <a:solidFill>
+                  <a:schemeClr val="tx2"/>
+                </a:solidFill>
+              </a:rPr>
+              <a:t>데이터 기반</a:t>
+            </a:r>
+            <a:endParaRPr lang="en-US" sz="850" dirty="0"/>
+          </a:p>
+          <a:p>
+            <a:pPr algn="ctr" indent="0" marL="0">
+              <a:buNone/>
+            </a:pPr>
+            <a:r>
+              <a:rPr lang="en-US" sz="850" dirty="0">
+                <a:solidFill>
+                  <a:schemeClr val="tx2"/>
+                </a:solidFill>
+              </a:rPr>
+              <a:t>설계·구현까지 경험</a:t>
+            </a:r>
+            <a:endParaRPr lang="en-US" sz="850" dirty="0"/>
+          </a:p>
+        </p:txBody>
+      </p:sp>
+      <p:sp>
+        <p:nvSpPr>
+          <p:cNvPr id="40" name="Shape 38"/>
+          <p:cNvSpPr/>
+          <p:nvPr/>
+        </p:nvSpPr>
+        <p:spPr>
+          <a:xfrm rot="10800000">
+            <a:off x="2724912" y="4279392"/>
+            <a:ext cx="219456" cy="109728"/>
+          </a:xfrm>
+          <a:prstGeom prst="triangle">
+            <a:avLst/>
+          </a:prstGeom>
+          <a:solidFill>
+            <a:schemeClr val="tx1"/>
+          </a:solidFill>
+          <a:ln/>
+        </p:spPr>
+      </p:sp>
+      <p:sp>
+        <p:nvSpPr>
+          <p:cNvPr id="41" name="Shape 39"/>
+          <p:cNvSpPr/>
+          <p:nvPr/>
+        </p:nvSpPr>
+        <p:spPr>
+          <a:xfrm>
+            <a:off x="1490472" y="4416552"/>
+            <a:ext cx="1316736" cy="329184"/>
+          </a:xfrm>
+          <a:prstGeom prst="rect">
+            <a:avLst/>
+          </a:prstGeom>
+          <a:solidFill>
+            <a:schemeClr val="bg1"/>
+          </a:solidFill>
+          <a:ln w="15875">
+            <a:solidFill>
+              <a:schemeClr val="accent3"/>
+            </a:solidFill>
+            <a:prstDash val="solid"/>
+          </a:ln>
+        </p:spPr>
+      </p:sp>
+      <p:sp>
+        <p:nvSpPr>
+          <p:cNvPr id="42" name="Text 40"/>
+          <p:cNvSpPr txBox="1"/>
+          <p:nvPr/>
+        </p:nvSpPr>
+        <p:spPr>
+          <a:xfrm>
+            <a:off x="1517904" y="4416552"/>
+            <a:ext cx="1261872" cy="329184"/>
+          </a:xfrm>
+          <a:prstGeom prst="rect">
+            <a:avLst/>
+          </a:prstGeom>
+          <a:noFill/>
+          <a:ln/>
+        </p:spPr>
+        <p:txBody>
+          <a:bodyPr wrap="square" lIns="0" tIns="0" rIns="0" bIns="0" rtlCol="0" anchor="ctr"/>
+          <a:lstStyle/>
+          <a:p>
+            <a:pPr algn="ctr" indent="0" marL="0">
+              <a:buNone/>
+            </a:pPr>
+            <a:r>
+              <a:rPr lang="en-US" sz="850" b="1" dirty="0">
+                <a:solidFill>
+                  <a:schemeClr val="accent3"/>
+                </a:solidFill>
+              </a:rPr>
+              <a:t>현업 주도 AX 과제</a:t>
+            </a:r>
+            <a:endParaRPr lang="en-US" sz="850" dirty="0"/>
+          </a:p>
+          <a:p>
+            <a:pPr algn="ctr" indent="0" marL="0">
+              <a:buNone/>
+            </a:pPr>
+            <a:r>
+              <a:rPr lang="en-US" sz="850" b="1" dirty="0">
+                <a:solidFill>
+                  <a:schemeClr val="accent3"/>
+                </a:solidFill>
+              </a:rPr>
+              <a:t>발굴 방법론 내재화</a:t>
+            </a:r>
+            <a:endParaRPr lang="en-US" sz="850" dirty="0"/>
+          </a:p>
+        </p:txBody>
+      </p:sp>
+      <p:sp>
+        <p:nvSpPr>
+          <p:cNvPr id="43" name="Shape 41"/>
+          <p:cNvSpPr/>
+          <p:nvPr/>
+        </p:nvSpPr>
+        <p:spPr>
+          <a:xfrm>
+            <a:off x="2862072" y="4416552"/>
+            <a:ext cx="1316736" cy="329184"/>
+          </a:xfrm>
+          <a:prstGeom prst="rect">
+            <a:avLst/>
+          </a:prstGeom>
+          <a:solidFill>
+            <a:schemeClr val="bg1"/>
+          </a:solidFill>
+          <a:ln w="15875">
+            <a:solidFill>
+              <a:schemeClr val="accent3"/>
+            </a:solidFill>
+            <a:prstDash val="solid"/>
+          </a:ln>
+        </p:spPr>
+      </p:sp>
+      <p:sp>
+        <p:nvSpPr>
+          <p:cNvPr id="44" name="Text 42"/>
+          <p:cNvSpPr txBox="1"/>
+          <p:nvPr/>
+        </p:nvSpPr>
+        <p:spPr>
+          <a:xfrm>
+            <a:off x="2889504" y="4416552"/>
+            <a:ext cx="1261872" cy="329184"/>
+          </a:xfrm>
+          <a:prstGeom prst="rect">
+            <a:avLst/>
+          </a:prstGeom>
+          <a:noFill/>
+          <a:ln/>
+        </p:spPr>
+        <p:txBody>
+          <a:bodyPr wrap="square" lIns="0" tIns="0" rIns="0" bIns="0" rtlCol="0" anchor="ctr"/>
+          <a:lstStyle/>
+          <a:p>
+            <a:pPr algn="ctr" indent="0" marL="0">
+              <a:buNone/>
+            </a:pPr>
+            <a:r>
+              <a:rPr lang="en-US" sz="850" b="1" dirty="0">
+                <a:solidFill>
+                  <a:schemeClr val="accent3"/>
+                </a:solidFill>
+              </a:rPr>
+              <a:t>AX진단 연계</a:t>
+            </a:r>
+            <a:endParaRPr lang="en-US" sz="850" dirty="0"/>
+          </a:p>
+          <a:p>
+            <a:pPr algn="ctr" indent="0" marL="0">
+              <a:buNone/>
+            </a:pPr>
+            <a:r>
+              <a:rPr lang="en-US" sz="850" b="1" dirty="0">
+                <a:solidFill>
+                  <a:schemeClr val="accent3"/>
+                </a:solidFill>
+              </a:rPr>
+              <a:t>→ 사업 Open Door</a:t>
+            </a:r>
+            <a:endParaRPr lang="en-US" sz="850" dirty="0"/>
+          </a:p>
+        </p:txBody>
+      </p:sp>
+      <p:sp>
+        <p:nvSpPr>
+          <p:cNvPr id="45" name="left-box-3"/>
+          <p:cNvSpPr/>
+          <p:nvPr/>
+        </p:nvSpPr>
+        <p:spPr>
+          <a:xfrm>
+            <a:off x="1417320" y="4946904"/>
+            <a:ext cx="2834640" cy="1600200"/>
           </a:xfrm>
           <a:prstGeom prst="rect">
             <a:avLst/>
@@ -1738,14 +2449,14 @@
       </p:sp>
       <p:sp>
         <p:nvSpPr>
-          <p:cNvPr id="24" name="Shape 22"/>
-          <p:cNvSpPr/>
-          <p:nvPr/>
-        </p:nvSpPr>
-        <p:spPr>
-          <a:xfrm>
-            <a:off x="1417320" y="4846320"/>
-            <a:ext cx="2834640" cy="310896"/>
+          <p:cNvPr id="46" name="Shape 44"/>
+          <p:cNvSpPr/>
+          <p:nvPr/>
+        </p:nvSpPr>
+        <p:spPr>
+          <a:xfrm>
+            <a:off x="1417320" y="4946904"/>
+            <a:ext cx="2834640" cy="246888"/>
           </a:xfrm>
           <a:prstGeom prst="rect">
             <a:avLst/>
@@ -1763,119 +2474,663 @@
       </p:sp>
       <p:sp>
         <p:nvSpPr>
-          <p:cNvPr id="25" name="Text 23"/>
-          <p:cNvSpPr txBox="1"/>
-          <p:nvPr/>
-        </p:nvSpPr>
-        <p:spPr>
-          <a:xfrm>
-            <a:off x="1417320" y="4846320"/>
-            <a:ext cx="2834640" cy="310896"/>
-          </a:xfrm>
-          <a:prstGeom prst="rect">
-            <a:avLst/>
-          </a:prstGeom>
-          <a:noFill/>
-          <a:ln/>
-        </p:spPr>
-        <p:txBody>
-          <a:bodyPr wrap="square" lIns="0" tIns="0" rIns="0" bIns="0" rtlCol="0" anchor="ctr"/>
-          <a:lstStyle/>
-          <a:p>
-            <a:pPr algn="ctr" indent="0" marL="0">
-              <a:buNone/>
-            </a:pPr>
-            <a:r>
-              <a:rPr lang="en-US" sz="1300" b="1" dirty="0">
+          <p:cNvPr id="47" name="Text 45"/>
+          <p:cNvSpPr txBox="1"/>
+          <p:nvPr/>
+        </p:nvSpPr>
+        <p:spPr>
+          <a:xfrm>
+            <a:off x="1417320" y="4946904"/>
+            <a:ext cx="2834640" cy="246888"/>
+          </a:xfrm>
+          <a:prstGeom prst="rect">
+            <a:avLst/>
+          </a:prstGeom>
+          <a:noFill/>
+          <a:ln/>
+        </p:spPr>
+        <p:txBody>
+          <a:bodyPr wrap="square" lIns="0" tIns="0" rIns="0" bIns="0" rtlCol="0" anchor="ctr"/>
+          <a:lstStyle/>
+          <a:p>
+            <a:pPr algn="ctr" indent="0" marL="0">
+              <a:buNone/>
+            </a:pPr>
+            <a:r>
+              <a:rPr lang="en-US" sz="1200" b="1" dirty="0">
                 <a:solidFill>
                   <a:schemeClr val="tx1"/>
                 </a:solidFill>
               </a:rPr>
-              <a:t>추진 범위</a:t>
-            </a:r>
-            <a:endParaRPr lang="en-US" sz="1300" dirty="0"/>
-          </a:p>
-        </p:txBody>
-      </p:sp>
-      <p:sp>
-        <p:nvSpPr>
-          <p:cNvPr id="26" name="Text 24"/>
+              <a:t>추진 단계</a:t>
+            </a:r>
+            <a:endParaRPr lang="en-US" sz="1200" dirty="0"/>
+          </a:p>
+        </p:txBody>
+      </p:sp>
+      <p:sp>
+        <p:nvSpPr>
+          <p:cNvPr id="48" name="left-stage-1"/>
+          <p:cNvSpPr/>
+          <p:nvPr/>
+        </p:nvSpPr>
+        <p:spPr>
+          <a:xfrm>
+            <a:off x="1490472" y="5230368"/>
+            <a:ext cx="969264" cy="384048"/>
+          </a:xfrm>
+          <a:prstGeom prst="homePlate">
+            <a:avLst/>
+          </a:prstGeom>
+          <a:solidFill>
+            <a:schemeClr val="accent4"/>
+          </a:solidFill>
+          <a:ln w="12700">
+            <a:solidFill>
+              <a:srgbClr val="FFFFFF"/>
+            </a:solidFill>
+            <a:prstDash val="solid"/>
+          </a:ln>
+        </p:spPr>
+      </p:sp>
+      <p:sp>
+        <p:nvSpPr>
+          <p:cNvPr id="49" name="Text 47"/>
           <p:cNvSpPr txBox="1"/>
           <p:nvPr/>
         </p:nvSpPr>
         <p:spPr>
           <a:xfrm>
             <a:off x="1508760" y="5230368"/>
-            <a:ext cx="2670048" cy="1234440"/>
-          </a:xfrm>
-          <a:prstGeom prst="rect">
-            <a:avLst/>
-          </a:prstGeom>
-          <a:noFill/>
-          <a:ln/>
-        </p:spPr>
-        <p:txBody>
-          <a:bodyPr wrap="square" lIns="0" tIns="0" rIns="0" bIns="0" rtlCol="0" anchor="t"/>
-          <a:lstStyle/>
-          <a:p>
-            <a:pPr marL="127000" indent="-127000">
-              <a:spcAft>
-                <a:spcPts val="400"/>
-              </a:spcAft>
-              <a:buSzPct val="100000"/>
-              <a:buChar char="•"/>
-            </a:pPr>
-            <a:r>
-              <a:rPr lang="en-US" sz="1050" dirty="0">
+            <a:ext cx="804672" cy="384048"/>
+          </a:xfrm>
+          <a:prstGeom prst="rect">
+            <a:avLst/>
+          </a:prstGeom>
+          <a:noFill/>
+          <a:ln/>
+        </p:spPr>
+        <p:txBody>
+          <a:bodyPr wrap="square" lIns="0" tIns="0" rIns="0" bIns="0" rtlCol="0" anchor="ctr"/>
+          <a:lstStyle/>
+          <a:p>
+            <a:pPr algn="ctr" indent="0" marL="0">
+              <a:buNone/>
+            </a:pPr>
+            <a:r>
+              <a:rPr lang="en-US" sz="800" b="1" dirty="0">
+                <a:solidFill>
+                  <a:schemeClr val="tx1"/>
+                </a:solidFill>
+              </a:rPr>
+              <a:t>1단계</a:t>
+            </a:r>
+            <a:endParaRPr lang="en-US" sz="800" dirty="0"/>
+          </a:p>
+          <a:p>
+            <a:pPr algn="ctr" indent="0" marL="0">
+              <a:buNone/>
+            </a:pPr>
+            <a:r>
+              <a:rPr lang="en-US" sz="800" b="1" dirty="0">
+                <a:solidFill>
+                  <a:schemeClr val="tx1"/>
+                </a:solidFill>
+              </a:rPr>
+              <a:t>AI 활용 역량</a:t>
+            </a:r>
+            <a:endParaRPr lang="en-US" sz="800" dirty="0"/>
+          </a:p>
+        </p:txBody>
+      </p:sp>
+      <p:sp>
+        <p:nvSpPr>
+          <p:cNvPr id="50" name="left-stage-2"/>
+          <p:cNvSpPr/>
+          <p:nvPr/>
+        </p:nvSpPr>
+        <p:spPr>
+          <a:xfrm>
+            <a:off x="2350008" y="5230368"/>
+            <a:ext cx="969264" cy="384048"/>
+          </a:xfrm>
+          <a:prstGeom prst="chevron">
+            <a:avLst/>
+          </a:prstGeom>
+          <a:solidFill>
+            <a:schemeClr val="accent1"/>
+          </a:solidFill>
+          <a:ln w="12700">
+            <a:solidFill>
+              <a:srgbClr val="FFFFFF"/>
+            </a:solidFill>
+            <a:prstDash val="solid"/>
+          </a:ln>
+        </p:spPr>
+      </p:sp>
+      <p:sp>
+        <p:nvSpPr>
+          <p:cNvPr id="51" name="Text 49"/>
+          <p:cNvSpPr txBox="1"/>
+          <p:nvPr/>
+        </p:nvSpPr>
+        <p:spPr>
+          <a:xfrm>
+            <a:off x="2478024" y="5230368"/>
+            <a:ext cx="694944" cy="384048"/>
+          </a:xfrm>
+          <a:prstGeom prst="rect">
+            <a:avLst/>
+          </a:prstGeom>
+          <a:noFill/>
+          <a:ln/>
+        </p:spPr>
+        <p:txBody>
+          <a:bodyPr wrap="square" lIns="0" tIns="0" rIns="0" bIns="0" rtlCol="0" anchor="ctr"/>
+          <a:lstStyle/>
+          <a:p>
+            <a:pPr algn="ctr" indent="0" marL="0">
+              <a:buNone/>
+            </a:pPr>
+            <a:r>
+              <a:rPr lang="en-US" sz="800" b="1" dirty="0">
+                <a:solidFill>
+                  <a:schemeClr val="bg1"/>
+                </a:solidFill>
+              </a:rPr>
+              <a:t>2단계</a:t>
+            </a:r>
+            <a:endParaRPr lang="en-US" sz="800" dirty="0"/>
+          </a:p>
+          <a:p>
+            <a:pPr algn="ctr" indent="0" marL="0">
+              <a:buNone/>
+            </a:pPr>
+            <a:r>
+              <a:rPr lang="en-US" sz="800" b="1" dirty="0">
+                <a:solidFill>
+                  <a:schemeClr val="bg1"/>
+                </a:solidFill>
+              </a:rPr>
+              <a:t>혁신 과제 발굴</a:t>
+            </a:r>
+            <a:endParaRPr lang="en-US" sz="800" dirty="0"/>
+          </a:p>
+        </p:txBody>
+      </p:sp>
+      <p:sp>
+        <p:nvSpPr>
+          <p:cNvPr id="52" name="left-stage-3"/>
+          <p:cNvSpPr/>
+          <p:nvPr/>
+        </p:nvSpPr>
+        <p:spPr>
+          <a:xfrm>
+            <a:off x="3209544" y="5230368"/>
+            <a:ext cx="969264" cy="384048"/>
+          </a:xfrm>
+          <a:prstGeom prst="chevron">
+            <a:avLst/>
+          </a:prstGeom>
+          <a:solidFill>
+            <a:schemeClr val="accent4"/>
+          </a:solidFill>
+          <a:ln w="12700">
+            <a:solidFill>
+              <a:srgbClr val="FFFFFF"/>
+            </a:solidFill>
+            <a:prstDash val="solid"/>
+          </a:ln>
+        </p:spPr>
+      </p:sp>
+      <p:sp>
+        <p:nvSpPr>
+          <p:cNvPr id="53" name="Text 51"/>
+          <p:cNvSpPr txBox="1"/>
+          <p:nvPr/>
+        </p:nvSpPr>
+        <p:spPr>
+          <a:xfrm>
+            <a:off x="3337560" y="5230368"/>
+            <a:ext cx="694944" cy="384048"/>
+          </a:xfrm>
+          <a:prstGeom prst="rect">
+            <a:avLst/>
+          </a:prstGeom>
+          <a:noFill/>
+          <a:ln/>
+        </p:spPr>
+        <p:txBody>
+          <a:bodyPr wrap="square" lIns="0" tIns="0" rIns="0" bIns="0" rtlCol="0" anchor="ctr"/>
+          <a:lstStyle/>
+          <a:p>
+            <a:pPr algn="ctr" indent="0" marL="0">
+              <a:buNone/>
+            </a:pPr>
+            <a:r>
+              <a:rPr lang="en-US" sz="800" b="1" dirty="0">
+                <a:solidFill>
+                  <a:schemeClr val="tx1"/>
+                </a:solidFill>
+              </a:rPr>
+              <a:t>3단계</a:t>
+            </a:r>
+            <a:endParaRPr lang="en-US" sz="800" dirty="0"/>
+          </a:p>
+          <a:p>
+            <a:pPr algn="ctr" indent="0" marL="0">
+              <a:buNone/>
+            </a:pPr>
+            <a:r>
+              <a:rPr lang="en-US" sz="800" b="1" dirty="0">
+                <a:solidFill>
+                  <a:schemeClr val="tx1"/>
+                </a:solidFill>
+              </a:rPr>
+              <a:t>사업 연계</a:t>
+            </a:r>
+            <a:endParaRPr lang="en-US" sz="800" dirty="0"/>
+          </a:p>
+        </p:txBody>
+      </p:sp>
+      <p:sp>
+        <p:nvSpPr>
+          <p:cNvPr id="54" name="Shape 52"/>
+          <p:cNvSpPr/>
+          <p:nvPr/>
+        </p:nvSpPr>
+        <p:spPr>
+          <a:xfrm>
+            <a:off x="1490472" y="5641848"/>
+            <a:ext cx="865632" cy="365760"/>
+          </a:xfrm>
+          <a:prstGeom prst="rect">
+            <a:avLst/>
+          </a:prstGeom>
+          <a:solidFill>
+            <a:schemeClr val="bg2"/>
+          </a:solidFill>
+          <a:ln w="6350">
+            <a:solidFill>
+              <a:schemeClr val="accent4"/>
+            </a:solidFill>
+            <a:prstDash val="solid"/>
+          </a:ln>
+        </p:spPr>
+      </p:sp>
+      <p:sp>
+        <p:nvSpPr>
+          <p:cNvPr id="55" name="Text 53"/>
+          <p:cNvSpPr txBox="1"/>
+          <p:nvPr/>
+        </p:nvSpPr>
+        <p:spPr>
+          <a:xfrm>
+            <a:off x="1517904" y="5641848"/>
+            <a:ext cx="810768" cy="365760"/>
+          </a:xfrm>
+          <a:prstGeom prst="rect">
+            <a:avLst/>
+          </a:prstGeom>
+          <a:noFill/>
+          <a:ln/>
+        </p:spPr>
+        <p:txBody>
+          <a:bodyPr wrap="square" lIns="0" tIns="0" rIns="0" bIns="0" rtlCol="0" anchor="ctr"/>
+          <a:lstStyle/>
+          <a:p>
+            <a:pPr algn="ctr" indent="0" marL="0">
+              <a:buNone/>
+            </a:pPr>
+            <a:r>
+              <a:rPr lang="en-US" sz="850" dirty="0">
                 <a:solidFill>
                   <a:schemeClr val="tx2"/>
                 </a:solidFill>
               </a:rPr>
-              <a:t>1차 Pilot: 롯데백화점 이커머스부문 ('26.10.30)</a:t>
-            </a:r>
-            <a:endParaRPr lang="en-US" sz="1050" dirty="0"/>
-          </a:p>
-          <a:p>
-            <a:pPr marL="127000" indent="-127000">
-              <a:spcAft>
-                <a:spcPts val="400"/>
-              </a:spcAft>
-              <a:buSzPct val="100000"/>
-              <a:buChar char="•"/>
-            </a:pPr>
-            <a:r>
-              <a:rPr lang="en-US" sz="1050" dirty="0">
+              <a:t>AI·Agent</a:t>
+            </a:r>
+            <a:endParaRPr lang="en-US" sz="850" dirty="0"/>
+          </a:p>
+          <a:p>
+            <a:pPr algn="ctr" indent="0" marL="0">
+              <a:buNone/>
+            </a:pPr>
+            <a:r>
+              <a:rPr lang="en-US" sz="850" dirty="0">
                 <a:solidFill>
                   <a:schemeClr val="tx2"/>
                 </a:solidFill>
               </a:rPr>
-              <a:t>데이터 분석 → 과제 도출 → 외부조사 → 기획서 → Agent 개발</a:t>
-            </a:r>
-            <a:endParaRPr lang="en-US" sz="1050" dirty="0"/>
-          </a:p>
-          <a:p>
-            <a:pPr marL="127000" indent="-127000">
-              <a:spcAft>
-                <a:spcPts val="400"/>
-              </a:spcAft>
-              <a:buSzPct val="100000"/>
-              <a:buChar char="•"/>
-            </a:pPr>
-            <a:r>
-              <a:rPr lang="en-US" sz="1050" dirty="0">
+              <a:t>업무 활용 실습</a:t>
+            </a:r>
+            <a:endParaRPr lang="en-US" sz="850" dirty="0"/>
+          </a:p>
+        </p:txBody>
+      </p:sp>
+      <p:sp>
+        <p:nvSpPr>
+          <p:cNvPr id="56" name="Shape 54"/>
+          <p:cNvSpPr/>
+          <p:nvPr/>
+        </p:nvSpPr>
+        <p:spPr>
+          <a:xfrm>
+            <a:off x="2401824" y="5641848"/>
+            <a:ext cx="865632" cy="365760"/>
+          </a:xfrm>
+          <a:prstGeom prst="rect">
+            <a:avLst/>
+          </a:prstGeom>
+          <a:solidFill>
+            <a:schemeClr val="bg2"/>
+          </a:solidFill>
+          <a:ln w="6350">
+            <a:solidFill>
+              <a:schemeClr val="accent4"/>
+            </a:solidFill>
+            <a:prstDash val="solid"/>
+          </a:ln>
+        </p:spPr>
+      </p:sp>
+      <p:sp>
+        <p:nvSpPr>
+          <p:cNvPr id="57" name="Text 55"/>
+          <p:cNvSpPr txBox="1"/>
+          <p:nvPr/>
+        </p:nvSpPr>
+        <p:spPr>
+          <a:xfrm>
+            <a:off x="2429256" y="5641848"/>
+            <a:ext cx="810768" cy="365760"/>
+          </a:xfrm>
+          <a:prstGeom prst="rect">
+            <a:avLst/>
+          </a:prstGeom>
+          <a:noFill/>
+          <a:ln/>
+        </p:spPr>
+        <p:txBody>
+          <a:bodyPr wrap="square" lIns="0" tIns="0" rIns="0" bIns="0" rtlCol="0" anchor="ctr"/>
+          <a:lstStyle/>
+          <a:p>
+            <a:pPr algn="ctr" indent="0" marL="0">
+              <a:buNone/>
+            </a:pPr>
+            <a:r>
+              <a:rPr lang="en-US" sz="850" dirty="0">
                 <a:solidFill>
                   <a:schemeClr val="tx2"/>
                 </a:solidFill>
               </a:rPr>
-              <a:t>'27년 업종별 데이터셋·시나리오 표준화 → 그룹사 확산</a:t>
-            </a:r>
-            <a:endParaRPr lang="en-US" sz="1050" dirty="0"/>
-          </a:p>
-        </p:txBody>
-      </p:sp>
-      <p:sp>
-        <p:nvSpPr>
-          <p:cNvPr id="27" name="approach-header"/>
+              <a:t>Pain Point →</a:t>
+            </a:r>
+            <a:endParaRPr lang="en-US" sz="850" dirty="0"/>
+          </a:p>
+          <a:p>
+            <a:pPr algn="ctr" indent="0" marL="0">
+              <a:buNone/>
+            </a:pPr>
+            <a:r>
+              <a:rPr lang="en-US" sz="850" dirty="0">
+                <a:solidFill>
+                  <a:schemeClr val="tx2"/>
+                </a:solidFill>
+              </a:rPr>
+              <a:t>Agent 구현</a:t>
+            </a:r>
+            <a:endParaRPr lang="en-US" sz="850" dirty="0"/>
+          </a:p>
+        </p:txBody>
+      </p:sp>
+      <p:sp>
+        <p:nvSpPr>
+          <p:cNvPr id="58" name="Shape 56"/>
+          <p:cNvSpPr/>
+          <p:nvPr/>
+        </p:nvSpPr>
+        <p:spPr>
+          <a:xfrm>
+            <a:off x="3313176" y="5641848"/>
+            <a:ext cx="865632" cy="365760"/>
+          </a:xfrm>
+          <a:prstGeom prst="rect">
+            <a:avLst/>
+          </a:prstGeom>
+          <a:solidFill>
+            <a:schemeClr val="bg2"/>
+          </a:solidFill>
+          <a:ln w="6350">
+            <a:solidFill>
+              <a:schemeClr val="accent4"/>
+            </a:solidFill>
+            <a:prstDash val="solid"/>
+          </a:ln>
+        </p:spPr>
+      </p:sp>
+      <p:sp>
+        <p:nvSpPr>
+          <p:cNvPr id="59" name="Text 57"/>
+          <p:cNvSpPr txBox="1"/>
+          <p:nvPr/>
+        </p:nvSpPr>
+        <p:spPr>
+          <a:xfrm>
+            <a:off x="3340608" y="5641848"/>
+            <a:ext cx="810768" cy="365760"/>
+          </a:xfrm>
+          <a:prstGeom prst="rect">
+            <a:avLst/>
+          </a:prstGeom>
+          <a:noFill/>
+          <a:ln/>
+        </p:spPr>
+        <p:txBody>
+          <a:bodyPr wrap="square" lIns="0" tIns="0" rIns="0" bIns="0" rtlCol="0" anchor="ctr"/>
+          <a:lstStyle/>
+          <a:p>
+            <a:pPr algn="ctr" indent="0" marL="0">
+              <a:buNone/>
+            </a:pPr>
+            <a:r>
+              <a:rPr lang="en-US" sz="850" dirty="0">
+                <a:solidFill>
+                  <a:schemeClr val="tx2"/>
+                </a:solidFill>
+              </a:rPr>
+              <a:t>과제 리스트 →</a:t>
+            </a:r>
+            <a:endParaRPr lang="en-US" sz="850" dirty="0"/>
+          </a:p>
+          <a:p>
+            <a:pPr algn="ctr" indent="0" marL="0">
+              <a:buNone/>
+            </a:pPr>
+            <a:r>
+              <a:rPr lang="en-US" sz="850" dirty="0">
+                <a:solidFill>
+                  <a:schemeClr val="tx2"/>
+                </a:solidFill>
+              </a:rPr>
+              <a:t>AX진단 제안</a:t>
+            </a:r>
+            <a:endParaRPr lang="en-US" sz="850" dirty="0"/>
+          </a:p>
+        </p:txBody>
+      </p:sp>
+      <p:sp>
+        <p:nvSpPr>
+          <p:cNvPr id="60" name="Shape 58"/>
+          <p:cNvSpPr/>
+          <p:nvPr/>
+        </p:nvSpPr>
+        <p:spPr>
+          <a:xfrm rot="10800000">
+            <a:off x="2724912" y="6035040"/>
+            <a:ext cx="219456" cy="109728"/>
+          </a:xfrm>
+          <a:prstGeom prst="triangle">
+            <a:avLst/>
+          </a:prstGeom>
+          <a:solidFill>
+            <a:schemeClr val="tx1"/>
+          </a:solidFill>
+          <a:ln/>
+        </p:spPr>
+      </p:sp>
+      <p:sp>
+        <p:nvSpPr>
+          <p:cNvPr id="61" name="Shape 59"/>
+          <p:cNvSpPr/>
+          <p:nvPr/>
+        </p:nvSpPr>
+        <p:spPr>
+          <a:xfrm>
+            <a:off x="1490472" y="6172200"/>
+            <a:ext cx="1316736" cy="329184"/>
+          </a:xfrm>
+          <a:prstGeom prst="rect">
+            <a:avLst/>
+          </a:prstGeom>
+          <a:solidFill>
+            <a:schemeClr val="bg1"/>
+          </a:solidFill>
+          <a:ln w="15875">
+            <a:solidFill>
+              <a:schemeClr val="accent3"/>
+            </a:solidFill>
+            <a:prstDash val="solid"/>
+          </a:ln>
+        </p:spPr>
+      </p:sp>
+      <p:sp>
+        <p:nvSpPr>
+          <p:cNvPr id="62" name="Text 60"/>
+          <p:cNvSpPr txBox="1"/>
+          <p:nvPr/>
+        </p:nvSpPr>
+        <p:spPr>
+          <a:xfrm>
+            <a:off x="1517904" y="6172200"/>
+            <a:ext cx="1261872" cy="329184"/>
+          </a:xfrm>
+          <a:prstGeom prst="rect">
+            <a:avLst/>
+          </a:prstGeom>
+          <a:noFill/>
+          <a:ln/>
+        </p:spPr>
+        <p:txBody>
+          <a:bodyPr wrap="square" lIns="0" tIns="0" rIns="0" bIns="0" rtlCol="0" anchor="ctr"/>
+          <a:lstStyle/>
+          <a:p>
+            <a:pPr algn="ctr" indent="0" marL="0">
+              <a:buNone/>
+            </a:pPr>
+            <a:r>
+              <a:rPr lang="en-US" sz="850" b="1" dirty="0">
+                <a:solidFill>
+                  <a:schemeClr val="accent3"/>
+                </a:solidFill>
+              </a:rPr>
+              <a:t>1차 Pilot: 롯데백화점</a:t>
+            </a:r>
+            <a:endParaRPr lang="en-US" sz="850" dirty="0"/>
+          </a:p>
+          <a:p>
+            <a:pPr algn="ctr" indent="0" marL="0">
+              <a:buNone/>
+            </a:pPr>
+            <a:r>
+              <a:rPr lang="en-US" sz="850" b="1" dirty="0">
+                <a:solidFill>
+                  <a:schemeClr val="accent3"/>
+                </a:solidFill>
+              </a:rPr>
+              <a:t>이커머스 ('26.10.30)</a:t>
+            </a:r>
+            <a:endParaRPr lang="en-US" sz="850" dirty="0"/>
+          </a:p>
+        </p:txBody>
+      </p:sp>
+      <p:sp>
+        <p:nvSpPr>
+          <p:cNvPr id="63" name="Shape 61"/>
+          <p:cNvSpPr/>
+          <p:nvPr/>
+        </p:nvSpPr>
+        <p:spPr>
+          <a:xfrm>
+            <a:off x="2862072" y="6172200"/>
+            <a:ext cx="1316736" cy="329184"/>
+          </a:xfrm>
+          <a:prstGeom prst="rect">
+            <a:avLst/>
+          </a:prstGeom>
+          <a:solidFill>
+            <a:schemeClr val="bg1"/>
+          </a:solidFill>
+          <a:ln w="15875">
+            <a:solidFill>
+              <a:schemeClr val="accent3"/>
+            </a:solidFill>
+            <a:prstDash val="solid"/>
+          </a:ln>
+        </p:spPr>
+      </p:sp>
+      <p:sp>
+        <p:nvSpPr>
+          <p:cNvPr id="64" name="Text 62"/>
+          <p:cNvSpPr txBox="1"/>
+          <p:nvPr/>
+        </p:nvSpPr>
+        <p:spPr>
+          <a:xfrm>
+            <a:off x="2889504" y="6172200"/>
+            <a:ext cx="1261872" cy="329184"/>
+          </a:xfrm>
+          <a:prstGeom prst="rect">
+            <a:avLst/>
+          </a:prstGeom>
+          <a:noFill/>
+          <a:ln/>
+        </p:spPr>
+        <p:txBody>
+          <a:bodyPr wrap="square" lIns="0" tIns="0" rIns="0" bIns="0" rtlCol="0" anchor="ctr"/>
+          <a:lstStyle/>
+          <a:p>
+            <a:pPr algn="ctr" indent="0" marL="0">
+              <a:buNone/>
+            </a:pPr>
+            <a:r>
+              <a:rPr lang="en-US" sz="850" b="1" dirty="0">
+                <a:solidFill>
+                  <a:schemeClr val="accent3"/>
+                </a:solidFill>
+              </a:rPr>
+              <a:t>'27 그룹사 확산 및</a:t>
+            </a:r>
+            <a:endParaRPr lang="en-US" sz="850" dirty="0"/>
+          </a:p>
+          <a:p>
+            <a:pPr algn="ctr" indent="0" marL="0">
+              <a:buNone/>
+            </a:pPr>
+            <a:r>
+              <a:rPr lang="en-US" sz="850" b="1" dirty="0">
+                <a:solidFill>
+                  <a:schemeClr val="accent3"/>
+                </a:solidFill>
+              </a:rPr>
+              <a:t>진단 연계 본격화</a:t>
+            </a:r>
+            <a:endParaRPr lang="en-US" sz="850" dirty="0"/>
+          </a:p>
+        </p:txBody>
+      </p:sp>
+      <p:sp>
+        <p:nvSpPr>
+          <p:cNvPr id="65" name="approach-header"/>
           <p:cNvSpPr/>
           <p:nvPr/>
         </p:nvSpPr>
@@ -1895,7 +3150,7 @@
       </p:sp>
       <p:sp>
         <p:nvSpPr>
-          <p:cNvPr id="28" name="Text 26"/>
+          <p:cNvPr id="66" name="Text 64"/>
           <p:cNvSpPr txBox="1"/>
           <p:nvPr/>
         </p:nvSpPr>
@@ -1931,7 +3186,7 @@
       </p:sp>
       <p:sp>
         <p:nvSpPr>
-          <p:cNvPr id="29" name="Text 27"/>
+          <p:cNvPr id="67" name="Text 65"/>
           <p:cNvSpPr txBox="1"/>
           <p:nvPr/>
         </p:nvSpPr>
@@ -1978,7 +3233,7 @@
       </p:sp>
       <p:sp>
         <p:nvSpPr>
-          <p:cNvPr id="30" name="row-label-1"/>
+          <p:cNvPr id="68" name="row-label-1"/>
           <p:cNvSpPr/>
           <p:nvPr/>
         </p:nvSpPr>
@@ -2003,7 +3258,7 @@
       </p:sp>
       <p:sp>
         <p:nvSpPr>
-          <p:cNvPr id="31" name="Text 29"/>
+          <p:cNvPr id="69" name="Text 67"/>
           <p:cNvSpPr txBox="1"/>
           <p:nvPr/>
         </p:nvSpPr>
@@ -2039,7 +3294,7 @@
       </p:sp>
       <p:sp>
         <p:nvSpPr>
-          <p:cNvPr id="32" name="Text 30"/>
+          <p:cNvPr id="70" name="Text 68"/>
           <p:cNvSpPr txBox="1"/>
           <p:nvPr/>
         </p:nvSpPr>
@@ -2097,7 +3352,7 @@
       </p:sp>
       <p:sp>
         <p:nvSpPr>
-          <p:cNvPr id="33" name="Text 31"/>
+          <p:cNvPr id="71" name="Text 69"/>
           <p:cNvSpPr txBox="1"/>
           <p:nvPr/>
         </p:nvSpPr>
@@ -2133,7 +3388,7 @@
       </p:sp>
       <p:sp>
         <p:nvSpPr>
-          <p:cNvPr id="34" name="Shape 32"/>
+          <p:cNvPr id="72" name="Shape 70"/>
           <p:cNvSpPr/>
           <p:nvPr/>
         </p:nvSpPr>
@@ -2158,7 +3413,7 @@
       </p:sp>
       <p:sp>
         <p:nvSpPr>
-          <p:cNvPr id="35" name="Shape 33"/>
+          <p:cNvPr id="73" name="Shape 71"/>
           <p:cNvSpPr/>
           <p:nvPr/>
         </p:nvSpPr>
@@ -2178,7 +3433,7 @@
       </p:sp>
       <p:sp>
         <p:nvSpPr>
-          <p:cNvPr id="36" name="Text 34"/>
+          <p:cNvPr id="74" name="Text 72"/>
           <p:cNvSpPr txBox="1"/>
           <p:nvPr/>
         </p:nvSpPr>
@@ -2214,7 +3469,7 @@
       </p:sp>
       <p:sp>
         <p:nvSpPr>
-          <p:cNvPr id="37" name="Text 35"/>
+          <p:cNvPr id="75" name="Text 73"/>
           <p:cNvSpPr txBox="1"/>
           <p:nvPr/>
         </p:nvSpPr>
@@ -2264,7 +3519,7 @@
       </p:sp>
       <p:sp>
         <p:nvSpPr>
-          <p:cNvPr id="38" name="Shape 36"/>
+          <p:cNvPr id="76" name="Shape 74"/>
           <p:cNvSpPr/>
           <p:nvPr/>
         </p:nvSpPr>
@@ -2284,7 +3539,7 @@
       </p:sp>
       <p:sp>
         <p:nvSpPr>
-          <p:cNvPr id="39" name="Shape 37"/>
+          <p:cNvPr id="77" name="Shape 75"/>
           <p:cNvSpPr/>
           <p:nvPr/>
         </p:nvSpPr>
@@ -2309,7 +3564,7 @@
       </p:sp>
       <p:sp>
         <p:nvSpPr>
-          <p:cNvPr id="40" name="Shape 38"/>
+          <p:cNvPr id="78" name="Shape 76"/>
           <p:cNvSpPr/>
           <p:nvPr/>
         </p:nvSpPr>
@@ -2329,7 +3584,7 @@
       </p:sp>
       <p:sp>
         <p:nvSpPr>
-          <p:cNvPr id="41" name="Text 39"/>
+          <p:cNvPr id="79" name="Text 77"/>
           <p:cNvSpPr txBox="1"/>
           <p:nvPr/>
         </p:nvSpPr>
@@ -2365,7 +3620,7 @@
       </p:sp>
       <p:sp>
         <p:nvSpPr>
-          <p:cNvPr id="42" name="Text 40"/>
+          <p:cNvPr id="80" name="Text 78"/>
           <p:cNvSpPr txBox="1"/>
           <p:nvPr/>
         </p:nvSpPr>
@@ -2415,7 +3670,7 @@
       </p:sp>
       <p:sp>
         <p:nvSpPr>
-          <p:cNvPr id="43" name="Shape 41"/>
+          <p:cNvPr id="81" name="Shape 79"/>
           <p:cNvSpPr/>
           <p:nvPr/>
         </p:nvSpPr>
@@ -2435,7 +3690,7 @@
       </p:sp>
       <p:sp>
         <p:nvSpPr>
-          <p:cNvPr id="44" name="Shape 42"/>
+          <p:cNvPr id="82" name="Shape 80"/>
           <p:cNvSpPr/>
           <p:nvPr/>
         </p:nvSpPr>
@@ -2460,7 +3715,7 @@
       </p:sp>
       <p:sp>
         <p:nvSpPr>
-          <p:cNvPr id="45" name="Shape 43"/>
+          <p:cNvPr id="83" name="Shape 81"/>
           <p:cNvSpPr/>
           <p:nvPr/>
         </p:nvSpPr>
@@ -2480,7 +3735,7 @@
       </p:sp>
       <p:sp>
         <p:nvSpPr>
-          <p:cNvPr id="46" name="Text 44"/>
+          <p:cNvPr id="84" name="Text 82"/>
           <p:cNvSpPr txBox="1"/>
           <p:nvPr/>
         </p:nvSpPr>
@@ -2516,7 +3771,7 @@
       </p:sp>
       <p:sp>
         <p:nvSpPr>
-          <p:cNvPr id="47" name="Text 45"/>
+          <p:cNvPr id="85" name="Text 83"/>
           <p:cNvSpPr txBox="1"/>
           <p:nvPr/>
         </p:nvSpPr>
@@ -2566,7 +3821,7 @@
       </p:sp>
       <p:sp>
         <p:nvSpPr>
-          <p:cNvPr id="48" name="Text 46"/>
+          <p:cNvPr id="86" name="Text 84"/>
           <p:cNvSpPr txBox="1"/>
           <p:nvPr/>
         </p:nvSpPr>
@@ -2602,7 +3857,7 @@
       </p:sp>
       <p:sp>
         <p:nvSpPr>
-          <p:cNvPr id="49" name="row-label-2"/>
+          <p:cNvPr id="87" name="row-label-2"/>
           <p:cNvSpPr/>
           <p:nvPr/>
         </p:nvSpPr>
@@ -2627,7 +3882,7 @@
       </p:sp>
       <p:sp>
         <p:nvSpPr>
-          <p:cNvPr id="50" name="Text 48"/>
+          <p:cNvPr id="88" name="Text 86"/>
           <p:cNvSpPr txBox="1"/>
           <p:nvPr/>
         </p:nvSpPr>
@@ -2663,7 +3918,7 @@
       </p:sp>
       <p:sp>
         <p:nvSpPr>
-          <p:cNvPr id="51" name="Text 49"/>
+          <p:cNvPr id="89" name="Text 87"/>
           <p:cNvSpPr txBox="1"/>
           <p:nvPr/>
         </p:nvSpPr>
@@ -2721,7 +3976,7 @@
       </p:sp>
       <p:sp>
         <p:nvSpPr>
-          <p:cNvPr id="52" name="Text 50"/>
+          <p:cNvPr id="90" name="Text 88"/>
           <p:cNvSpPr txBox="1"/>
           <p:nvPr/>
         </p:nvSpPr>
@@ -2757,7 +4012,7 @@
       </p:sp>
       <p:sp>
         <p:nvSpPr>
-          <p:cNvPr id="53" name="Shape 51"/>
+          <p:cNvPr id="91" name="Shape 89"/>
           <p:cNvSpPr/>
           <p:nvPr/>
         </p:nvSpPr>
@@ -2782,7 +4037,7 @@
       </p:sp>
       <p:sp>
         <p:nvSpPr>
-          <p:cNvPr id="54" name="Shape 52"/>
+          <p:cNvPr id="92" name="Shape 90"/>
           <p:cNvSpPr/>
           <p:nvPr/>
         </p:nvSpPr>
@@ -2802,7 +4057,7 @@
       </p:sp>
       <p:sp>
         <p:nvSpPr>
-          <p:cNvPr id="55" name="Text 53"/>
+          <p:cNvPr id="93" name="Text 91"/>
           <p:cNvSpPr txBox="1"/>
           <p:nvPr/>
         </p:nvSpPr>
@@ -2838,7 +4093,7 @@
       </p:sp>
       <p:sp>
         <p:nvSpPr>
-          <p:cNvPr id="56" name="Text 54"/>
+          <p:cNvPr id="94" name="Text 92"/>
           <p:cNvSpPr txBox="1"/>
           <p:nvPr/>
         </p:nvSpPr>
@@ -2888,7 +4143,7 @@
       </p:sp>
       <p:sp>
         <p:nvSpPr>
-          <p:cNvPr id="57" name="Shape 55"/>
+          <p:cNvPr id="95" name="Shape 93"/>
           <p:cNvSpPr/>
           <p:nvPr/>
         </p:nvSpPr>
@@ -2908,7 +4163,7 @@
       </p:sp>
       <p:sp>
         <p:nvSpPr>
-          <p:cNvPr id="58" name="Shape 56"/>
+          <p:cNvPr id="96" name="Shape 94"/>
           <p:cNvSpPr/>
           <p:nvPr/>
         </p:nvSpPr>
@@ -2933,7 +4188,7 @@
       </p:sp>
       <p:sp>
         <p:nvSpPr>
-          <p:cNvPr id="59" name="Shape 57"/>
+          <p:cNvPr id="97" name="Shape 95"/>
           <p:cNvSpPr/>
           <p:nvPr/>
         </p:nvSpPr>
@@ -2953,7 +4208,7 @@
       </p:sp>
       <p:sp>
         <p:nvSpPr>
-          <p:cNvPr id="60" name="Text 58"/>
+          <p:cNvPr id="98" name="Text 96"/>
           <p:cNvSpPr txBox="1"/>
           <p:nvPr/>
         </p:nvSpPr>
@@ -2989,7 +4244,7 @@
       </p:sp>
       <p:sp>
         <p:nvSpPr>
-          <p:cNvPr id="61" name="Text 59"/>
+          <p:cNvPr id="99" name="Text 97"/>
           <p:cNvSpPr txBox="1"/>
           <p:nvPr/>
         </p:nvSpPr>
@@ -3039,7 +4294,7 @@
       </p:sp>
       <p:sp>
         <p:nvSpPr>
-          <p:cNvPr id="62" name="Shape 60"/>
+          <p:cNvPr id="100" name="Shape 98"/>
           <p:cNvSpPr/>
           <p:nvPr/>
         </p:nvSpPr>
@@ -3059,7 +4314,7 @@
       </p:sp>
       <p:sp>
         <p:nvSpPr>
-          <p:cNvPr id="63" name="Shape 61"/>
+          <p:cNvPr id="101" name="Shape 99"/>
           <p:cNvSpPr/>
           <p:nvPr/>
         </p:nvSpPr>
@@ -3084,7 +4339,7 @@
       </p:sp>
       <p:sp>
         <p:nvSpPr>
-          <p:cNvPr id="64" name="Shape 62"/>
+          <p:cNvPr id="102" name="Shape 100"/>
           <p:cNvSpPr/>
           <p:nvPr/>
         </p:nvSpPr>
@@ -3104,7 +4359,7 @@
       </p:sp>
       <p:sp>
         <p:nvSpPr>
-          <p:cNvPr id="65" name="Text 63"/>
+          <p:cNvPr id="103" name="Text 101"/>
           <p:cNvSpPr txBox="1"/>
           <p:nvPr/>
         </p:nvSpPr>
@@ -3140,7 +4395,7 @@
       </p:sp>
       <p:sp>
         <p:nvSpPr>
-          <p:cNvPr id="66" name="Text 64"/>
+          <p:cNvPr id="104" name="Text 102"/>
           <p:cNvSpPr txBox="1"/>
           <p:nvPr/>
         </p:nvSpPr>
@@ -3190,7 +4445,7 @@
       </p:sp>
       <p:sp>
         <p:nvSpPr>
-          <p:cNvPr id="67" name="row-label-3"/>
+          <p:cNvPr id="105" name="row-label-3"/>
           <p:cNvSpPr/>
           <p:nvPr/>
         </p:nvSpPr>
@@ -3215,7 +4470,7 @@
       </p:sp>
       <p:sp>
         <p:nvSpPr>
-          <p:cNvPr id="68" name="Text 66"/>
+          <p:cNvPr id="106" name="Text 104"/>
           <p:cNvSpPr txBox="1"/>
           <p:nvPr/>
         </p:nvSpPr>
@@ -3293,7 +4548,7 @@
       </p:sp>
       <p:sp>
         <p:nvSpPr>
-          <p:cNvPr id="69" name="Text 67"/>
+          <p:cNvPr id="107" name="Text 105"/>
           <p:cNvSpPr txBox="1"/>
           <p:nvPr/>
         </p:nvSpPr>
@@ -3351,7 +4606,7 @@
       </p:sp>
       <p:sp>
         <p:nvSpPr>
-          <p:cNvPr id="70" name="Text 68"/>
+          <p:cNvPr id="108" name="Text 106"/>
           <p:cNvSpPr txBox="1"/>
           <p:nvPr/>
         </p:nvSpPr>
@@ -3379,7 +4634,7 @@
       </p:sp>
       <p:sp>
         <p:nvSpPr>
-          <p:cNvPr id="71" name="plan-step-1"/>
+          <p:cNvPr id="109" name="plan-step-1"/>
           <p:cNvSpPr/>
           <p:nvPr/>
         </p:nvSpPr>
@@ -3404,7 +4659,7 @@
       </p:sp>
       <p:sp>
         <p:nvSpPr>
-          <p:cNvPr id="72" name="Text 70"/>
+          <p:cNvPr id="110" name="Text 108"/>
           <p:cNvSpPr txBox="1"/>
           <p:nvPr/>
         </p:nvSpPr>
@@ -3454,7 +4709,7 @@
       </p:sp>
       <p:sp>
         <p:nvSpPr>
-          <p:cNvPr id="73" name="Text 71"/>
+          <p:cNvPr id="111" name="Text 109"/>
           <p:cNvSpPr txBox="1"/>
           <p:nvPr/>
         </p:nvSpPr>
@@ -3490,7 +4745,7 @@
       </p:sp>
       <p:sp>
         <p:nvSpPr>
-          <p:cNvPr id="74" name="plan-step-2"/>
+          <p:cNvPr id="112" name="plan-step-2"/>
           <p:cNvSpPr/>
           <p:nvPr/>
         </p:nvSpPr>
@@ -3515,7 +4770,7 @@
       </p:sp>
       <p:sp>
         <p:nvSpPr>
-          <p:cNvPr id="75" name="Text 73"/>
+          <p:cNvPr id="113" name="Text 111"/>
           <p:cNvSpPr txBox="1"/>
           <p:nvPr/>
         </p:nvSpPr>
@@ -3565,7 +4820,7 @@
       </p:sp>
       <p:sp>
         <p:nvSpPr>
-          <p:cNvPr id="76" name="Text 74"/>
+          <p:cNvPr id="114" name="Text 112"/>
           <p:cNvSpPr txBox="1"/>
           <p:nvPr/>
         </p:nvSpPr>
@@ -3601,7 +4856,7 @@
       </p:sp>
       <p:sp>
         <p:nvSpPr>
-          <p:cNvPr id="77" name="plan-step-3"/>
+          <p:cNvPr id="115" name="plan-step-3"/>
           <p:cNvSpPr/>
           <p:nvPr/>
         </p:nvSpPr>
@@ -3626,7 +4881,7 @@
       </p:sp>
       <p:sp>
         <p:nvSpPr>
-          <p:cNvPr id="78" name="Text 76"/>
+          <p:cNvPr id="116" name="Text 114"/>
           <p:cNvSpPr txBox="1"/>
           <p:nvPr/>
         </p:nvSpPr>
@@ -3676,7 +4931,7 @@
       </p:sp>
       <p:sp>
         <p:nvSpPr>
-          <p:cNvPr id="79" name="Text 77"/>
+          <p:cNvPr id="117" name="Text 115"/>
           <p:cNvSpPr txBox="1"/>
           <p:nvPr/>
         </p:nvSpPr>
@@ -3712,7 +4967,7 @@
       </p:sp>
       <p:sp>
         <p:nvSpPr>
-          <p:cNvPr id="80" name="plan-step-4"/>
+          <p:cNvPr id="118" name="plan-step-4"/>
           <p:cNvSpPr/>
           <p:nvPr/>
         </p:nvSpPr>
@@ -3737,7 +4992,7 @@
       </p:sp>
       <p:sp>
         <p:nvSpPr>
-          <p:cNvPr id="81" name="Text 79"/>
+          <p:cNvPr id="119" name="Text 117"/>
           <p:cNvSpPr txBox="1"/>
           <p:nvPr/>
         </p:nvSpPr>
@@ -3787,7 +5042,7 @@
       </p:sp>
       <p:sp>
         <p:nvSpPr>
-          <p:cNvPr id="82" name="Text 80"/>
+          <p:cNvPr id="120" name="Text 118"/>
           <p:cNvSpPr txBox="1"/>
           <p:nvPr/>
         </p:nvSpPr>
@@ -3823,7 +5078,7 @@
       </p:sp>
       <p:sp>
         <p:nvSpPr>
-          <p:cNvPr id="83" name="plan-step-5"/>
+          <p:cNvPr id="121" name="plan-step-5"/>
           <p:cNvSpPr/>
           <p:nvPr/>
         </p:nvSpPr>
@@ -3848,7 +5103,7 @@
       </p:sp>
       <p:sp>
         <p:nvSpPr>
-          <p:cNvPr id="84" name="Text 82"/>
+          <p:cNvPr id="122" name="Text 120"/>
           <p:cNvSpPr txBox="1"/>
           <p:nvPr/>
         </p:nvSpPr>
@@ -3898,7 +5153,7 @@
       </p:sp>
       <p:sp>
         <p:nvSpPr>
-          <p:cNvPr id="85" name="Text 83"/>
+          <p:cNvPr id="123" name="Text 121"/>
           <p:cNvSpPr txBox="1"/>
           <p:nvPr/>
         </p:nvSpPr>
@@ -3934,7 +5189,7 @@
       </p:sp>
       <p:sp>
         <p:nvSpPr>
-          <p:cNvPr id="86" name="Text 84"/>
+          <p:cNvPr id="124" name="Text 122"/>
           <p:cNvSpPr txBox="1"/>
           <p:nvPr/>
         </p:nvSpPr>

</xml_diff>